<commit_message>
Add macOS distribution and runtime onboarding support
</commit_message>
<xml_diff>
--- a/sidecar/2026年AI在智慧城市中的发展.pptx
+++ b/sidecar/2026年AI在智慧城市中的发展.pptx
@@ -16,6 +16,7 @@
     <p:sldId id="264" r:id="rId15"/>
     <p:sldId id="265" r:id="rId16"/>
     <p:sldId id="266" r:id="rId17"/>
+    <p:sldId id="267" r:id="rId18"/>
   </p:sldIdLst>
   <p:sldSz cx="9144000" cy="6858000" type="screen4x3"/>
   <p:notesSz cx="6858000" cy="9144000"/>
@@ -3091,14 +3092,6 @@
 <file path=ppt/slides/slide1.xml><?xml version="1.0" encoding="utf-8"?>
 <p:sld xmlns:a="http://schemas.openxmlformats.org/drawingml/2006/main" xmlns:p="http://schemas.openxmlformats.org/presentationml/2006/main" xmlns:r="http://schemas.openxmlformats.org/officeDocument/2006/relationships">
   <p:cSld>
-    <p:bg>
-      <p:bgPr>
-        <a:solidFill>
-          <a:srgbClr val="0F4C81"/>
-        </a:solidFill>
-        <a:effectLst/>
-      </p:bgPr>
-    </p:bg>
     <p:spTree>
       <p:nvGrpSpPr>
         <p:cNvPr id="1" name=""/>
@@ -3114,8 +3107,8 @@
         </p:nvSpPr>
         <p:spPr>
           <a:xfrm>
-            <a:off x="457200" y="2286000"/>
-            <a:ext cx="8229600" cy="914400"/>
+            <a:off x="914400" y="2286000"/>
+            <a:ext cx="7315200" cy="914400"/>
           </a:xfrm>
           <a:prstGeom prst="rect">
             <a:avLst/>
@@ -3129,9 +3122,9 @@
           <a:lstStyle/>
           <a:p>
             <a:pPr algn="ctr">
-              <a:defRPr sz="4800" b="1">
+              <a:defRPr sz="4400" b="1">
                 <a:solidFill>
-                  <a:srgbClr val="FFFFFF"/>
+                  <a:srgbClr val="003366"/>
                 </a:solidFill>
               </a:defRPr>
             </a:pPr>
@@ -3149,8 +3142,8 @@
         </p:nvSpPr>
         <p:spPr>
           <a:xfrm>
-            <a:off x="457200" y="3657600"/>
-            <a:ext cx="8229600" cy="731520"/>
+            <a:off x="914400" y="3474720"/>
+            <a:ext cx="7315200" cy="731520"/>
           </a:xfrm>
           <a:prstGeom prst="rect">
             <a:avLst/>
@@ -3166,12 +3159,12 @@
             <a:pPr algn="ctr">
               <a:defRPr sz="2400">
                 <a:solidFill>
-                  <a:srgbClr val="C8DCF0"/>
+                  <a:srgbClr val="646464"/>
                 </a:solidFill>
               </a:defRPr>
             </a:pPr>
             <a:r>
-              <a:t>技术创新 · 应用场景 · 未来展望</a:t>
+              <a:t>人工智能驱动的城市未来</a:t>
             </a:r>
           </a:p>
         </p:txBody>
@@ -3196,59 +3189,14 @@
       <p:grpSpPr/>
       <p:sp>
         <p:nvSpPr>
-          <p:cNvPr id="2" name="Rectangle 1"/>
-          <p:cNvSpPr/>
+          <p:cNvPr id="2" name="TextBox 1"/>
+          <p:cNvSpPr txBox="1"/>
           <p:nvPr/>
         </p:nvSpPr>
         <p:spPr>
           <a:xfrm>
-            <a:off x="0" y="0"/>
-            <a:ext cx="9144000" cy="914400"/>
-          </a:xfrm>
-          <a:prstGeom prst="rect">
-            <a:avLst/>
-          </a:prstGeom>
-          <a:solidFill>
-            <a:srgbClr val="0F4C81"/>
-          </a:solidFill>
-          <a:ln>
-            <a:solidFill>
-              <a:srgbClr val="0F4C81"/>
-            </a:solidFill>
-          </a:ln>
-        </p:spPr>
-        <p:style>
-          <a:lnRef idx="1">
-            <a:schemeClr val="accent1"/>
-          </a:lnRef>
-          <a:fillRef idx="3">
-            <a:schemeClr val="accent1"/>
-          </a:fillRef>
-          <a:effectRef idx="2">
-            <a:schemeClr val="accent1"/>
-          </a:effectRef>
-          <a:fontRef idx="minor">
-            <a:schemeClr val="lt1"/>
-          </a:fontRef>
-        </p:style>
-        <p:txBody>
-          <a:bodyPr rtlCol="0" anchor="ctr"/>
-          <a:lstStyle/>
-          <a:p>
-            <a:pPr algn="ctr"/>
-          </a:p>
-        </p:txBody>
-      </p:sp>
-      <p:sp>
-        <p:nvSpPr>
-          <p:cNvPr id="3" name="TextBox 2"/>
-          <p:cNvSpPr txBox="1"/>
-          <p:nvPr/>
-        </p:nvSpPr>
-        <p:spPr>
-          <a:xfrm>
-            <a:off x="457200" y="182880"/>
-            <a:ext cx="8229600" cy="548640"/>
+            <a:off x="457200" y="457200"/>
+            <a:ext cx="8229600" cy="731520"/>
           </a:xfrm>
           <a:prstGeom prst="rect">
             <a:avLst/>
@@ -3264,26 +3212,26 @@
             <a:pPr>
               <a:defRPr sz="3200" b="1">
                 <a:solidFill>
-                  <a:srgbClr val="FFFFFF"/>
+                  <a:srgbClr val="003366"/>
                 </a:solidFill>
               </a:defRPr>
             </a:pPr>
             <a:r>
-              <a:t>05 未来展望</a:t>
-            </a:r>
-          </a:p>
-        </p:txBody>
-      </p:sp>
-      <p:sp>
-        <p:nvSpPr>
-          <p:cNvPr id="4" name="TextBox 3"/>
+              <a:t>5. 未来展望（上）</a:t>
+            </a:r>
+          </a:p>
+        </p:txBody>
+      </p:sp>
+      <p:sp>
+        <p:nvSpPr>
+          <p:cNvPr id="3" name="TextBox 2"/>
           <p:cNvSpPr txBox="1"/>
           <p:nvPr/>
         </p:nvSpPr>
         <p:spPr>
           <a:xfrm>
             <a:off x="731520" y="1371600"/>
-            <a:ext cx="7680960" cy="5029200"/>
+            <a:ext cx="7772400" cy="5029200"/>
           </a:xfrm>
           <a:prstGeom prst="rect">
             <a:avLst/>
@@ -3300,275 +3248,95 @@
               <a:spcBef>
                 <a:spcPts val="1200"/>
               </a:spcBef>
-              <a:defRPr sz="1800">
-                <a:solidFill>
-                  <a:srgbClr val="323232"/>
-                </a:solidFill>
-              </a:defRPr>
-            </a:pPr>
-            <a:r>
-              <a:t>技术演进方向</a:t>
-            </a:r>
-          </a:p>
-          <a:p>
-            <a:pPr>
-              <a:spcBef>
-                <a:spcPts val="1200"/>
-              </a:spcBef>
-              <a:defRPr sz="1800">
-                <a:solidFill>
-                  <a:srgbClr val="323232"/>
-                </a:solidFill>
-              </a:defRPr>
-            </a:pPr>
-            <a:r>
-              <a:t>   AI从辅助工具演变为城市运营的核心驱动力</a:t>
-            </a:r>
-          </a:p>
-          <a:p>
-            <a:pPr>
-              <a:spcBef>
-                <a:spcPts val="1200"/>
-              </a:spcBef>
-              <a:defRPr sz="1800">
-                <a:solidFill>
-                  <a:srgbClr val="323232"/>
-                </a:solidFill>
-              </a:defRPr>
-            </a:pPr>
-            <a:r>
-              <a:t>   智慧城市进入2.0阶段：从连接到思考与行动</a:t>
-            </a:r>
-          </a:p>
-          <a:p>
-            <a:pPr>
-              <a:spcBef>
-                <a:spcPts val="1200"/>
-              </a:spcBef>
-              <a:defRPr sz="1800">
-                <a:solidFill>
-                  <a:srgbClr val="323232"/>
-                </a:solidFill>
-              </a:defRPr>
-            </a:pPr>
-            <a:r>
-              <a:t>   人机协同治理模式成为主流</a:t>
-            </a:r>
-          </a:p>
-          <a:p>
-            <a:pPr>
-              <a:spcBef>
-                <a:spcPts val="1200"/>
-              </a:spcBef>
-              <a:defRPr sz="1800">
-                <a:solidFill>
-                  <a:srgbClr val="323232"/>
-                </a:solidFill>
-              </a:defRPr>
-            </a:pPr>
-          </a:p>
-          <a:p>
-            <a:pPr>
-              <a:spcBef>
-                <a:spcPts val="1200"/>
-              </a:spcBef>
-              <a:defRPr sz="1800">
-                <a:solidFill>
-                  <a:srgbClr val="323232"/>
-                </a:solidFill>
-              </a:defRPr>
-            </a:pPr>
-            <a:r>
-              <a:t>应用深化趋势</a:t>
-            </a:r>
-          </a:p>
-          <a:p>
-            <a:pPr>
-              <a:spcBef>
-                <a:spcPts val="1200"/>
-              </a:spcBef>
-              <a:defRPr sz="1800">
-                <a:solidFill>
-                  <a:srgbClr val="323232"/>
-                </a:solidFill>
-              </a:defRPr>
-            </a:pPr>
-            <a:r>
-              <a:t>   从单点应用到全域智能化</a:t>
-            </a:r>
-          </a:p>
-          <a:p>
-            <a:pPr>
-              <a:spcBef>
-                <a:spcPts val="1200"/>
-              </a:spcBef>
-              <a:defRPr sz="1800">
-                <a:solidFill>
-                  <a:srgbClr val="323232"/>
-                </a:solidFill>
-              </a:defRPr>
-            </a:pPr>
-            <a:r>
-              <a:t>   从被动响应到主动预测和干预</a:t>
-            </a:r>
-          </a:p>
-          <a:p>
-            <a:pPr>
-              <a:spcBef>
-                <a:spcPts val="1200"/>
-              </a:spcBef>
-              <a:defRPr sz="1800">
-                <a:solidFill>
-                  <a:srgbClr val="323232"/>
-                </a:solidFill>
-              </a:defRPr>
-            </a:pPr>
-            <a:r>
-              <a:t>   从技术驱动到以人为本的服务创新</a:t>
-            </a:r>
-          </a:p>
-          <a:p>
-            <a:pPr>
-              <a:spcBef>
-                <a:spcPts val="1200"/>
-              </a:spcBef>
-              <a:defRPr sz="1800">
-                <a:solidFill>
-                  <a:srgbClr val="323232"/>
-                </a:solidFill>
-              </a:defRPr>
-            </a:pPr>
-          </a:p>
-          <a:p>
-            <a:pPr>
-              <a:spcBef>
-                <a:spcPts val="1200"/>
-              </a:spcBef>
-              <a:defRPr sz="1800">
-                <a:solidFill>
-                  <a:srgbClr val="323232"/>
-                </a:solidFill>
-              </a:defRPr>
-            </a:pPr>
-            <a:r>
-              <a:t>全球协同发展</a:t>
-            </a:r>
-          </a:p>
-          <a:p>
-            <a:pPr>
-              <a:spcBef>
-                <a:spcPts val="1200"/>
-              </a:spcBef>
-              <a:defRPr sz="1800">
-                <a:solidFill>
-                  <a:srgbClr val="323232"/>
-                </a:solidFill>
-              </a:defRPr>
-            </a:pPr>
-            <a:r>
-              <a:t>   国际标准和规范逐步建立</a:t>
-            </a:r>
-          </a:p>
-          <a:p>
-            <a:pPr>
-              <a:spcBef>
-                <a:spcPts val="1200"/>
-              </a:spcBef>
-              <a:defRPr sz="1800">
-                <a:solidFill>
-                  <a:srgbClr val="323232"/>
-                </a:solidFill>
-              </a:defRPr>
-            </a:pPr>
-            <a:r>
-              <a:t>   跨城市、跨国家的数据共享和协作</a:t>
-            </a:r>
-          </a:p>
-          <a:p>
-            <a:pPr>
-              <a:spcBef>
-                <a:spcPts val="1200"/>
-              </a:spcBef>
-              <a:defRPr sz="1800">
-                <a:solidFill>
-                  <a:srgbClr val="323232"/>
-                </a:solidFill>
-              </a:defRPr>
-            </a:pPr>
-            <a:r>
-              <a:t>   智慧城市经验和技术的全球推广</a:t>
-            </a:r>
-          </a:p>
-          <a:p>
-            <a:pPr>
-              <a:spcBef>
-                <a:spcPts val="1200"/>
-              </a:spcBef>
-              <a:defRPr sz="1800">
-                <a:solidFill>
-                  <a:srgbClr val="323232"/>
-                </a:solidFill>
-              </a:defRPr>
-            </a:pPr>
-          </a:p>
-          <a:p>
-            <a:pPr>
-              <a:spcBef>
-                <a:spcPts val="1200"/>
-              </a:spcBef>
-              <a:defRPr sz="1800">
-                <a:solidFill>
-                  <a:srgbClr val="323232"/>
-                </a:solidFill>
-              </a:defRPr>
-            </a:pPr>
-            <a:r>
-              <a:t>挑战与机遇并存</a:t>
-            </a:r>
-          </a:p>
-          <a:p>
-            <a:pPr>
-              <a:spcBef>
-                <a:spcPts val="1200"/>
-              </a:spcBef>
-              <a:defRPr sz="1800">
-                <a:solidFill>
-                  <a:srgbClr val="323232"/>
-                </a:solidFill>
-              </a:defRPr>
-            </a:pPr>
-            <a:r>
-              <a:t>   数据隐私和安全保护</a:t>
-            </a:r>
-          </a:p>
-          <a:p>
-            <a:pPr>
-              <a:spcBef>
-                <a:spcPts val="1200"/>
-              </a:spcBef>
-              <a:defRPr sz="1800">
-                <a:solidFill>
-                  <a:srgbClr val="323232"/>
-                </a:solidFill>
-              </a:defRPr>
-            </a:pPr>
-            <a:r>
-              <a:t>   数字鸿沟和公平性问题</a:t>
-            </a:r>
-          </a:p>
-          <a:p>
-            <a:pPr>
-              <a:spcBef>
-                <a:spcPts val="1200"/>
-              </a:spcBef>
-              <a:defRPr sz="1800">
-                <a:solidFill>
-                  <a:srgbClr val="323232"/>
-                </a:solidFill>
-              </a:defRPr>
-            </a:pPr>
-            <a:r>
-              <a:t>   技术伦理和治理框架完善</a:t>
+              <a:defRPr sz="1800"/>
+            </a:pPr>
+            <a:r>
+              <a:t>• 技术演进方向</a:t>
+            </a:r>
+          </a:p>
+          <a:p>
+            <a:pPr>
+              <a:spcBef>
+                <a:spcPts val="1200"/>
+              </a:spcBef>
+              <a:defRPr sz="1800"/>
+            </a:pPr>
+            <a:r>
+              <a:t>  - AI从辅助工具向自主智能体演进</a:t>
+            </a:r>
+          </a:p>
+          <a:p>
+            <a:pPr>
+              <a:spcBef>
+                <a:spcPts val="1200"/>
+              </a:spcBef>
+              <a:defRPr sz="1800"/>
+            </a:pPr>
+            <a:r>
+              <a:t>  - 多模态AI融合（视觉、语音、文本）</a:t>
+            </a:r>
+          </a:p>
+          <a:p>
+            <a:pPr>
+              <a:spcBef>
+                <a:spcPts val="1200"/>
+              </a:spcBef>
+              <a:defRPr sz="1800"/>
+            </a:pPr>
+            <a:r>
+              <a:t>  - 具身智能在城市场景的广泛应用</a:t>
+            </a:r>
+          </a:p>
+          <a:p>
+            <a:pPr>
+              <a:spcBef>
+                <a:spcPts val="1200"/>
+              </a:spcBef>
+              <a:defRPr sz="1800"/>
+            </a:pPr>
+          </a:p>
+          <a:p>
+            <a:pPr>
+              <a:spcBef>
+                <a:spcPts val="1200"/>
+              </a:spcBef>
+              <a:defRPr sz="1800"/>
+            </a:pPr>
+            <a:r>
+              <a:t>• 应用深化趋势</a:t>
+            </a:r>
+          </a:p>
+          <a:p>
+            <a:pPr>
+              <a:spcBef>
+                <a:spcPts val="1200"/>
+              </a:spcBef>
+              <a:defRPr sz="1800"/>
+            </a:pPr>
+            <a:r>
+              <a:t>  - 从单点应用向全域智能转变</a:t>
+            </a:r>
+          </a:p>
+          <a:p>
+            <a:pPr>
+              <a:spcBef>
+                <a:spcPts val="1200"/>
+              </a:spcBef>
+              <a:defRPr sz="1800"/>
+            </a:pPr>
+            <a:r>
+              <a:t>  - 跨部门数据打通与协同治理</a:t>
+            </a:r>
+          </a:p>
+          <a:p>
+            <a:pPr>
+              <a:spcBef>
+                <a:spcPts val="1200"/>
+              </a:spcBef>
+              <a:defRPr sz="1800"/>
+            </a:pPr>
+            <a:r>
+              <a:t>  - AI模型行业化、场景化定制</a:t>
             </a:r>
           </a:p>
         </p:txBody>
@@ -3584,14 +3352,6 @@
 <file path=ppt/slides/slide11.xml><?xml version="1.0" encoding="utf-8"?>
 <p:sld xmlns:a="http://schemas.openxmlformats.org/drawingml/2006/main" xmlns:p="http://schemas.openxmlformats.org/presentationml/2006/main" xmlns:r="http://schemas.openxmlformats.org/officeDocument/2006/relationships">
   <p:cSld>
-    <p:bg>
-      <p:bgPr>
-        <a:solidFill>
-          <a:srgbClr val="0F4C81"/>
-        </a:solidFill>
-        <a:effectLst/>
-      </p:bgPr>
-    </p:bg>
     <p:spTree>
       <p:nvGrpSpPr>
         <p:cNvPr id="1" name=""/>
@@ -3607,8 +3367,8 @@
         </p:nvSpPr>
         <p:spPr>
           <a:xfrm>
-            <a:off x="457200" y="2286000"/>
-            <a:ext cx="8229600" cy="1371600"/>
+            <a:off x="457200" y="457200"/>
+            <a:ext cx="8229600" cy="731520"/>
           </a:xfrm>
           <a:prstGeom prst="rect">
             <a:avLst/>
@@ -3621,15 +3381,15 @@
           </a:bodyPr>
           <a:lstStyle/>
           <a:p>
-            <a:pPr algn="ctr">
-              <a:defRPr sz="5400" b="1">
+            <a:pPr>
+              <a:defRPr sz="3200" b="1">
                 <a:solidFill>
-                  <a:srgbClr val="FFFFFF"/>
+                  <a:srgbClr val="003366"/>
                 </a:solidFill>
               </a:defRPr>
             </a:pPr>
             <a:r>
-              <a:t>谢谢观看</a:t>
+              <a:t>5. 未来展望（下）</a:t>
             </a:r>
           </a:p>
         </p:txBody>
@@ -3642,8 +3402,8 @@
         </p:nvSpPr>
         <p:spPr>
           <a:xfrm>
-            <a:off x="457200" y="3840480"/>
-            <a:ext cx="8229600" cy="548640"/>
+            <a:off x="731520" y="1371600"/>
+            <a:ext cx="7772400" cy="5029200"/>
           </a:xfrm>
           <a:prstGeom prst="rect">
             <a:avLst/>
@@ -3651,20 +3411,203 @@
           <a:noFill/>
         </p:spPr>
         <p:txBody>
+          <a:bodyPr wrap="square">
+            <a:spAutoFit/>
+          </a:bodyPr>
+          <a:lstStyle/>
+          <a:p>
+            <a:pPr>
+              <a:spcBef>
+                <a:spcPts val="1200"/>
+              </a:spcBef>
+              <a:defRPr sz="1800"/>
+            </a:pPr>
+            <a:r>
+              <a:t>• 挑战与机遇</a:t>
+            </a:r>
+          </a:p>
+          <a:p>
+            <a:pPr>
+              <a:spcBef>
+                <a:spcPts val="1200"/>
+              </a:spcBef>
+              <a:defRPr sz="1800"/>
+            </a:pPr>
+            <a:r>
+              <a:t>  - 隐私保护与数据安全</a:t>
+            </a:r>
+          </a:p>
+          <a:p>
+            <a:pPr>
+              <a:spcBef>
+                <a:spcPts val="1200"/>
+              </a:spcBef>
+              <a:defRPr sz="1800"/>
+            </a:pPr>
+            <a:r>
+              <a:t>  - 算法公平性与伦理问题</a:t>
+            </a:r>
+          </a:p>
+          <a:p>
+            <a:pPr>
+              <a:spcBef>
+                <a:spcPts val="1200"/>
+              </a:spcBef>
+              <a:defRPr sz="1800"/>
+            </a:pPr>
+            <a:r>
+              <a:t>  - 网络安全威胁应对</a:t>
+            </a:r>
+          </a:p>
+          <a:p>
+            <a:pPr>
+              <a:spcBef>
+                <a:spcPts val="1200"/>
+              </a:spcBef>
+              <a:defRPr sz="1800"/>
+            </a:pPr>
+            <a:r>
+              <a:t>  - 数字鸿沟与包容性发展</a:t>
+            </a:r>
+          </a:p>
+          <a:p>
+            <a:pPr>
+              <a:spcBef>
+                <a:spcPts val="1200"/>
+              </a:spcBef>
+              <a:defRPr sz="1800"/>
+            </a:pPr>
+          </a:p>
+          <a:p>
+            <a:pPr>
+              <a:spcBef>
+                <a:spcPts val="1200"/>
+              </a:spcBef>
+              <a:defRPr sz="1800"/>
+            </a:pPr>
+            <a:r>
+              <a:t>• 发展目标</a:t>
+            </a:r>
+          </a:p>
+          <a:p>
+            <a:pPr>
+              <a:spcBef>
+                <a:spcPts val="1200"/>
+              </a:spcBef>
+              <a:defRPr sz="1800"/>
+            </a:pPr>
+            <a:r>
+              <a:t>  - 2027年：65%全球城市部署AI智能体</a:t>
+            </a:r>
+          </a:p>
+          <a:p>
+            <a:pPr>
+              <a:spcBef>
+                <a:spcPts val="1200"/>
+              </a:spcBef>
+              <a:defRPr sz="1800"/>
+            </a:pPr>
+            <a:r>
+              <a:t>  - 中国AI核心产业规模持续增长</a:t>
+            </a:r>
+          </a:p>
+          <a:p>
+            <a:pPr>
+              <a:spcBef>
+                <a:spcPts val="1200"/>
+              </a:spcBef>
+              <a:defRPr sz="1800"/>
+            </a:pPr>
+            <a:r>
+              <a:t>  - 智慧城市成为数字中国建设综合载体</a:t>
+            </a:r>
+          </a:p>
+        </p:txBody>
+      </p:sp>
+    </p:spTree>
+  </p:cSld>
+  <p:clrMapOvr>
+    <a:masterClrMapping/>
+  </p:clrMapOvr>
+</p:sld>
+</file>
+
+<file path=ppt/slides/slide12.xml><?xml version="1.0" encoding="utf-8"?>
+<p:sld xmlns:a="http://schemas.openxmlformats.org/drawingml/2006/main" xmlns:p="http://schemas.openxmlformats.org/presentationml/2006/main" xmlns:r="http://schemas.openxmlformats.org/officeDocument/2006/relationships">
+  <p:cSld>
+    <p:spTree>
+      <p:nvGrpSpPr>
+        <p:cNvPr id="1" name=""/>
+        <p:cNvGrpSpPr/>
+        <p:nvPr/>
+      </p:nvGrpSpPr>
+      <p:grpSpPr/>
+      <p:sp>
+        <p:nvSpPr>
+          <p:cNvPr id="2" name="TextBox 1"/>
+          <p:cNvSpPr txBox="1"/>
+          <p:nvPr/>
+        </p:nvSpPr>
+        <p:spPr>
+          <a:xfrm>
+            <a:off x="914400" y="2286000"/>
+            <a:ext cx="7315200" cy="914400"/>
+          </a:xfrm>
+          <a:prstGeom prst="rect">
+            <a:avLst/>
+          </a:prstGeom>
+          <a:noFill/>
+        </p:spPr>
+        <p:txBody>
           <a:bodyPr wrap="none">
             <a:spAutoFit/>
           </a:bodyPr>
           <a:lstStyle/>
           <a:p>
             <a:pPr algn="ctr">
+              <a:defRPr sz="4400" b="1">
+                <a:solidFill>
+                  <a:srgbClr val="003366"/>
+                </a:solidFill>
+              </a:defRPr>
+            </a:pPr>
+            <a:r>
+              <a:t>谢谢观看</a:t>
+            </a:r>
+          </a:p>
+        </p:txBody>
+      </p:sp>
+      <p:sp>
+        <p:nvSpPr>
+          <p:cNvPr id="3" name="TextBox 2"/>
+          <p:cNvSpPr txBox="1"/>
+          <p:nvPr/>
+        </p:nvSpPr>
+        <p:spPr>
+          <a:xfrm>
+            <a:off x="914400" y="3474720"/>
+            <a:ext cx="7315200" cy="731520"/>
+          </a:xfrm>
+          <a:prstGeom prst="rect">
+            <a:avLst/>
+          </a:prstGeom>
+          <a:noFill/>
+        </p:spPr>
+        <p:txBody>
+          <a:bodyPr wrap="none">
+            <a:spAutoFit/>
+          </a:bodyPr>
+          <a:lstStyle/>
+          <a:p>
+            <a:pPr algn="ctr">
               <a:defRPr sz="2400">
                 <a:solidFill>
-                  <a:srgbClr val="C8DCF0"/>
+                  <a:srgbClr val="646464"/>
                 </a:solidFill>
               </a:defRPr>
             </a:pPr>
             <a:r>
-              <a:t>AI赋能智慧城市，共创美好未来</a:t>
+              <a:t>AI赋能，智慧未来</a:t>
             </a:r>
           </a:p>
         </p:txBody>
@@ -3689,59 +3632,14 @@
       <p:grpSpPr/>
       <p:sp>
         <p:nvSpPr>
-          <p:cNvPr id="2" name="Rectangle 1"/>
-          <p:cNvSpPr/>
+          <p:cNvPr id="2" name="TextBox 1"/>
+          <p:cNvSpPr txBox="1"/>
           <p:nvPr/>
         </p:nvSpPr>
         <p:spPr>
           <a:xfrm>
-            <a:off x="0" y="0"/>
-            <a:ext cx="9144000" cy="914400"/>
-          </a:xfrm>
-          <a:prstGeom prst="rect">
-            <a:avLst/>
-          </a:prstGeom>
-          <a:solidFill>
-            <a:srgbClr val="0F4C81"/>
-          </a:solidFill>
-          <a:ln>
-            <a:solidFill>
-              <a:srgbClr val="0F4C81"/>
-            </a:solidFill>
-          </a:ln>
-        </p:spPr>
-        <p:style>
-          <a:lnRef idx="1">
-            <a:schemeClr val="accent1"/>
-          </a:lnRef>
-          <a:fillRef idx="3">
-            <a:schemeClr val="accent1"/>
-          </a:fillRef>
-          <a:effectRef idx="2">
-            <a:schemeClr val="accent1"/>
-          </a:effectRef>
-          <a:fontRef idx="minor">
-            <a:schemeClr val="lt1"/>
-          </a:fontRef>
-        </p:style>
-        <p:txBody>
-          <a:bodyPr rtlCol="0" anchor="ctr"/>
-          <a:lstStyle/>
-          <a:p>
-            <a:pPr algn="ctr"/>
-          </a:p>
-        </p:txBody>
-      </p:sp>
-      <p:sp>
-        <p:nvSpPr>
-          <p:cNvPr id="3" name="TextBox 2"/>
-          <p:cNvSpPr txBox="1"/>
-          <p:nvPr/>
-        </p:nvSpPr>
-        <p:spPr>
-          <a:xfrm>
-            <a:off x="457200" y="182880"/>
-            <a:ext cx="8229600" cy="548640"/>
+            <a:off x="457200" y="457200"/>
+            <a:ext cx="8229600" cy="731520"/>
           </a:xfrm>
           <a:prstGeom prst="rect">
             <a:avLst/>
@@ -3757,7 +3655,7 @@
             <a:pPr>
               <a:defRPr sz="3200" b="1">
                 <a:solidFill>
-                  <a:srgbClr val="FFFFFF"/>
+                  <a:srgbClr val="003366"/>
                 </a:solidFill>
               </a:defRPr>
             </a:pPr>
@@ -3769,14 +3667,14 @@
       </p:sp>
       <p:sp>
         <p:nvSpPr>
-          <p:cNvPr id="4" name="TextBox 3"/>
+          <p:cNvPr id="3" name="TextBox 2"/>
           <p:cNvSpPr txBox="1"/>
           <p:nvPr/>
         </p:nvSpPr>
         <p:spPr>
           <a:xfrm>
-            <a:off x="1828800" y="1828800"/>
-            <a:ext cx="5486400" cy="4114800"/>
+            <a:off x="731520" y="1371600"/>
+            <a:ext cx="7772400" cy="5029200"/>
           </a:xfrm>
           <a:prstGeom prst="rect">
             <a:avLst/>
@@ -3784,83 +3682,63 @@
           <a:noFill/>
         </p:spPr>
         <p:txBody>
-          <a:bodyPr wrap="none">
+          <a:bodyPr wrap="square">
             <a:spAutoFit/>
           </a:bodyPr>
           <a:lstStyle/>
           <a:p>
             <a:pPr>
               <a:spcBef>
-                <a:spcPts val="2000"/>
-              </a:spcBef>
-              <a:defRPr sz="2400" b="1">
-                <a:solidFill>
-                  <a:srgbClr val="0F4C81"/>
-                </a:solidFill>
-              </a:defRPr>
-            </a:pPr>
-            <a:r>
-              <a:t>01  智慧城市的定义和发展背景</a:t>
-            </a:r>
-          </a:p>
-          <a:p>
-            <a:pPr>
-              <a:spcBef>
-                <a:spcPts val="2000"/>
-              </a:spcBef>
-              <a:defRPr sz="2400" b="1">
-                <a:solidFill>
-                  <a:srgbClr val="0F4C81"/>
-                </a:solidFill>
-              </a:defRPr>
-            </a:pPr>
-            <a:r>
-              <a:t>02  AI在智慧城市中的主要应用场景</a:t>
-            </a:r>
-          </a:p>
-          <a:p>
-            <a:pPr>
-              <a:spcBef>
-                <a:spcPts val="2000"/>
-              </a:spcBef>
-              <a:defRPr sz="2400" b="1">
-                <a:solidFill>
-                  <a:srgbClr val="0F4C81"/>
-                </a:solidFill>
-              </a:defRPr>
-            </a:pPr>
-            <a:r>
-              <a:t>03  2026年最新技术和趋势</a:t>
-            </a:r>
-          </a:p>
-          <a:p>
-            <a:pPr>
-              <a:spcBef>
-                <a:spcPts val="2000"/>
-              </a:spcBef>
-              <a:defRPr sz="2400" b="1">
-                <a:solidFill>
-                  <a:srgbClr val="0F4C81"/>
-                </a:solidFill>
-              </a:defRPr>
-            </a:pPr>
-            <a:r>
-              <a:t>04  成功案例分析</a:t>
-            </a:r>
-          </a:p>
-          <a:p>
-            <a:pPr>
-              <a:spcBef>
-                <a:spcPts val="2000"/>
-              </a:spcBef>
-              <a:defRPr sz="2400" b="1">
-                <a:solidFill>
-                  <a:srgbClr val="0F4C81"/>
-                </a:solidFill>
-              </a:defRPr>
-            </a:pPr>
-            <a:r>
-              <a:t>05  未来展望</a:t>
+                <a:spcPts val="1200"/>
+              </a:spcBef>
+              <a:defRPr sz="1800"/>
+            </a:pPr>
+            <a:r>
+              <a:t>1. 智慧城市的定义和发展背景</a:t>
+            </a:r>
+          </a:p>
+          <a:p>
+            <a:pPr>
+              <a:spcBef>
+                <a:spcPts val="1200"/>
+              </a:spcBef>
+              <a:defRPr sz="1800"/>
+            </a:pPr>
+            <a:r>
+              <a:t>2. AI在智慧城市中的主要应用场景</a:t>
+            </a:r>
+          </a:p>
+          <a:p>
+            <a:pPr>
+              <a:spcBef>
+                <a:spcPts val="1200"/>
+              </a:spcBef>
+              <a:defRPr sz="1800"/>
+            </a:pPr>
+            <a:r>
+              <a:t>3. 2026年最新技术和趋势</a:t>
+            </a:r>
+          </a:p>
+          <a:p>
+            <a:pPr>
+              <a:spcBef>
+                <a:spcPts val="1200"/>
+              </a:spcBef>
+              <a:defRPr sz="1800"/>
+            </a:pPr>
+            <a:r>
+              <a:t>4. 成功案例分析</a:t>
+            </a:r>
+          </a:p>
+          <a:p>
+            <a:pPr>
+              <a:spcBef>
+                <a:spcPts val="1200"/>
+              </a:spcBef>
+              <a:defRPr sz="1800"/>
+            </a:pPr>
+            <a:r>
+              <a:t>5. 未来展望</a:t>
             </a:r>
           </a:p>
         </p:txBody>
@@ -3885,59 +3763,14 @@
       <p:grpSpPr/>
       <p:sp>
         <p:nvSpPr>
-          <p:cNvPr id="2" name="Rectangle 1"/>
-          <p:cNvSpPr/>
+          <p:cNvPr id="2" name="TextBox 1"/>
+          <p:cNvSpPr txBox="1"/>
           <p:nvPr/>
         </p:nvSpPr>
         <p:spPr>
           <a:xfrm>
-            <a:off x="0" y="0"/>
-            <a:ext cx="9144000" cy="914400"/>
-          </a:xfrm>
-          <a:prstGeom prst="rect">
-            <a:avLst/>
-          </a:prstGeom>
-          <a:solidFill>
-            <a:srgbClr val="0F4C81"/>
-          </a:solidFill>
-          <a:ln>
-            <a:solidFill>
-              <a:srgbClr val="0F4C81"/>
-            </a:solidFill>
-          </a:ln>
-        </p:spPr>
-        <p:style>
-          <a:lnRef idx="1">
-            <a:schemeClr val="accent1"/>
-          </a:lnRef>
-          <a:fillRef idx="3">
-            <a:schemeClr val="accent1"/>
-          </a:fillRef>
-          <a:effectRef idx="2">
-            <a:schemeClr val="accent1"/>
-          </a:effectRef>
-          <a:fontRef idx="minor">
-            <a:schemeClr val="lt1"/>
-          </a:fontRef>
-        </p:style>
-        <p:txBody>
-          <a:bodyPr rtlCol="0" anchor="ctr"/>
-          <a:lstStyle/>
-          <a:p>
-            <a:pPr algn="ctr"/>
-          </a:p>
-        </p:txBody>
-      </p:sp>
-      <p:sp>
-        <p:nvSpPr>
-          <p:cNvPr id="3" name="TextBox 2"/>
-          <p:cNvSpPr txBox="1"/>
-          <p:nvPr/>
-        </p:nvSpPr>
-        <p:spPr>
-          <a:xfrm>
-            <a:off x="457200" y="182880"/>
-            <a:ext cx="8229600" cy="548640"/>
+            <a:off x="457200" y="457200"/>
+            <a:ext cx="8229600" cy="731520"/>
           </a:xfrm>
           <a:prstGeom prst="rect">
             <a:avLst/>
@@ -3953,26 +3786,26 @@
             <a:pPr>
               <a:defRPr sz="3200" b="1">
                 <a:solidFill>
-                  <a:srgbClr val="FFFFFF"/>
+                  <a:srgbClr val="003366"/>
                 </a:solidFill>
               </a:defRPr>
             </a:pPr>
             <a:r>
-              <a:t>01 智慧城市的定义和发展背景</a:t>
-            </a:r>
-          </a:p>
-        </p:txBody>
-      </p:sp>
-      <p:sp>
-        <p:nvSpPr>
-          <p:cNvPr id="4" name="TextBox 3"/>
+              <a:t>1. 智慧城市的定义和发展背景</a:t>
+            </a:r>
+          </a:p>
+        </p:txBody>
+      </p:sp>
+      <p:sp>
+        <p:nvSpPr>
+          <p:cNvPr id="3" name="TextBox 2"/>
           <p:cNvSpPr txBox="1"/>
           <p:nvPr/>
         </p:nvSpPr>
         <p:spPr>
           <a:xfrm>
             <a:off x="731520" y="1371600"/>
-            <a:ext cx="7680960" cy="5029200"/>
+            <a:ext cx="7772400" cy="5029200"/>
           </a:xfrm>
           <a:prstGeom prst="rect">
             <a:avLst/>
@@ -3989,173 +3822,73 @@
               <a:spcBef>
                 <a:spcPts val="1200"/>
               </a:spcBef>
-              <a:defRPr sz="1800">
-                <a:solidFill>
-                  <a:srgbClr val="323232"/>
-                </a:solidFill>
-              </a:defRPr>
-            </a:pPr>
-            <a:r>
-              <a:t>智慧城市定义</a:t>
-            </a:r>
-          </a:p>
-          <a:p>
-            <a:pPr>
-              <a:spcBef>
-                <a:spcPts val="1200"/>
-              </a:spcBef>
-              <a:defRPr sz="1800">
-                <a:solidFill>
-                  <a:srgbClr val="323232"/>
-                </a:solidFill>
-              </a:defRPr>
-            </a:pPr>
-            <a:r>
-              <a:t>   利用物联网、云计算、大数据、人工智能等新一代信息技术</a:t>
-            </a:r>
-          </a:p>
-          <a:p>
-            <a:pPr>
-              <a:spcBef>
-                <a:spcPts val="1200"/>
-              </a:spcBef>
-              <a:defRPr sz="1800">
-                <a:solidFill>
-                  <a:srgbClr val="323232"/>
-                </a:solidFill>
-              </a:defRPr>
-            </a:pPr>
-            <a:r>
-              <a:t>   实现城市智慧化管理和运行，提升城市治理效率和居民生活质量</a:t>
-            </a:r>
-          </a:p>
-          <a:p>
-            <a:pPr>
-              <a:spcBef>
-                <a:spcPts val="1200"/>
-              </a:spcBef>
-              <a:defRPr sz="1800">
-                <a:solidFill>
-                  <a:srgbClr val="323232"/>
-                </a:solidFill>
-              </a:defRPr>
-            </a:pPr>
-          </a:p>
-          <a:p>
-            <a:pPr>
-              <a:spcBef>
-                <a:spcPts val="1200"/>
-              </a:spcBef>
-              <a:defRPr sz="1800">
-                <a:solidFill>
-                  <a:srgbClr val="323232"/>
-                </a:solidFill>
-              </a:defRPr>
-            </a:pPr>
-            <a:r>
-              <a:t>市场规模</a:t>
-            </a:r>
-          </a:p>
-          <a:p>
-            <a:pPr>
-              <a:spcBef>
-                <a:spcPts val="1200"/>
-              </a:spcBef>
-              <a:defRPr sz="1800">
-                <a:solidFill>
-                  <a:srgbClr val="323232"/>
-                </a:solidFill>
-              </a:defRPr>
-            </a:pPr>
-            <a:r>
-              <a:t>   全球智慧城市市场：2025年699.7亿美元 -&gt; 2030年1445.6亿美元（CAGR 15.6%）</a:t>
-            </a:r>
-          </a:p>
-          <a:p>
-            <a:pPr>
-              <a:spcBef>
-                <a:spcPts val="1200"/>
-              </a:spcBef>
-              <a:defRPr sz="1800">
-                <a:solidFill>
-                  <a:srgbClr val="323232"/>
-                </a:solidFill>
-              </a:defRPr>
-            </a:pPr>
-            <a:r>
-              <a:t>   AI在智慧城市市场：2025年2000亿美元 -&gt; 2033年12000亿美元</a:t>
-            </a:r>
-          </a:p>
-          <a:p>
-            <a:pPr>
-              <a:spcBef>
-                <a:spcPts val="1200"/>
-              </a:spcBef>
-              <a:defRPr sz="1800">
-                <a:solidFill>
-                  <a:srgbClr val="323232"/>
-                </a:solidFill>
-              </a:defRPr>
-            </a:pPr>
-          </a:p>
-          <a:p>
-            <a:pPr>
-              <a:spcBef>
-                <a:spcPts val="1200"/>
-              </a:spcBef>
-              <a:defRPr sz="1800">
-                <a:solidFill>
-                  <a:srgbClr val="323232"/>
-                </a:solidFill>
-              </a:defRPr>
-            </a:pPr>
-            <a:r>
-              <a:t>全球发展态势</a:t>
-            </a:r>
-          </a:p>
-          <a:p>
-            <a:pPr>
-              <a:spcBef>
-                <a:spcPts val="1200"/>
-              </a:spcBef>
-              <a:defRPr sz="1800">
-                <a:solidFill>
-                  <a:srgbClr val="323232"/>
-                </a:solidFill>
-              </a:defRPr>
-            </a:pPr>
-            <a:r>
-              <a:t>   亚洲地区呈现最高成长速度</a:t>
-            </a:r>
-          </a:p>
-          <a:p>
-            <a:pPr>
-              <a:spcBef>
-                <a:spcPts val="1200"/>
-              </a:spcBef>
-              <a:defRPr sz="1800">
-                <a:solidFill>
-                  <a:srgbClr val="323232"/>
-                </a:solidFill>
-              </a:defRPr>
-            </a:pPr>
-            <a:r>
-              <a:t>   迪拜、阿布扎比首次进入2025智慧城市指数前5位</a:t>
-            </a:r>
-          </a:p>
-          <a:p>
-            <a:pPr>
-              <a:spcBef>
-                <a:spcPts val="1200"/>
-              </a:spcBef>
-              <a:defRPr sz="1800">
-                <a:solidFill>
-                  <a:srgbClr val="323232"/>
-                </a:solidFill>
-              </a:defRPr>
-            </a:pPr>
-            <a:r>
-              <a:t>   中国、新加坡、卡塔尔等国家积极推进智慧城市建设</a:t>
+              <a:defRPr sz="1800"/>
+            </a:pPr>
+            <a:r>
+              <a:t>• 定义：利用信息技术、物联网、大数据、云计算、人工智能等先进技术，面向城市治理、民生服务、产业发展、生态环保等核心场景的综合解决方案</a:t>
+            </a:r>
+          </a:p>
+          <a:p>
+            <a:pPr>
+              <a:spcBef>
+                <a:spcPts val="1200"/>
+              </a:spcBef>
+              <a:defRPr sz="1800"/>
+            </a:pPr>
+          </a:p>
+          <a:p>
+            <a:pPr>
+              <a:spcBef>
+                <a:spcPts val="1200"/>
+              </a:spcBef>
+              <a:defRPr sz="1800"/>
+            </a:pPr>
+            <a:r>
+              <a:t>• 发展背景：</a:t>
+            </a:r>
+          </a:p>
+          <a:p>
+            <a:pPr>
+              <a:spcBef>
+                <a:spcPts val="1200"/>
+              </a:spcBef>
+              <a:defRPr sz="1800"/>
+            </a:pPr>
+            <a:r>
+              <a:t>  - 全球城市化进程加速，城市管理面临复杂挑战</a:t>
+            </a:r>
+          </a:p>
+          <a:p>
+            <a:pPr>
+              <a:spcBef>
+                <a:spcPts val="1200"/>
+              </a:spcBef>
+              <a:defRPr sz="1800"/>
+            </a:pPr>
+            <a:r>
+              <a:t>  - AI技术成熟度提升，为智慧城市提供核心驱动力</a:t>
+            </a:r>
+          </a:p>
+          <a:p>
+            <a:pPr>
+              <a:spcBef>
+                <a:spcPts val="1200"/>
+              </a:spcBef>
+              <a:defRPr sz="1800"/>
+            </a:pPr>
+            <a:r>
+              <a:t>  - 中国智慧城市IT解决方案市场规模突破1.2万亿元</a:t>
+            </a:r>
+          </a:p>
+          <a:p>
+            <a:pPr>
+              <a:spcBef>
+                <a:spcPts val="1200"/>
+              </a:spcBef>
+              <a:defRPr sz="1800"/>
+            </a:pPr>
+            <a:r>
+              <a:t>  - 城市全域数字化转型成为国家战略重点</a:t>
             </a:r>
           </a:p>
         </p:txBody>
@@ -4180,59 +3913,14 @@
       <p:grpSpPr/>
       <p:sp>
         <p:nvSpPr>
-          <p:cNvPr id="2" name="Rectangle 1"/>
-          <p:cNvSpPr/>
+          <p:cNvPr id="2" name="TextBox 1"/>
+          <p:cNvSpPr txBox="1"/>
           <p:nvPr/>
         </p:nvSpPr>
         <p:spPr>
           <a:xfrm>
-            <a:off x="0" y="0"/>
-            <a:ext cx="9144000" cy="914400"/>
-          </a:xfrm>
-          <a:prstGeom prst="rect">
-            <a:avLst/>
-          </a:prstGeom>
-          <a:solidFill>
-            <a:srgbClr val="0F4C81"/>
-          </a:solidFill>
-          <a:ln>
-            <a:solidFill>
-              <a:srgbClr val="0F4C81"/>
-            </a:solidFill>
-          </a:ln>
-        </p:spPr>
-        <p:style>
-          <a:lnRef idx="1">
-            <a:schemeClr val="accent1"/>
-          </a:lnRef>
-          <a:fillRef idx="3">
-            <a:schemeClr val="accent1"/>
-          </a:fillRef>
-          <a:effectRef idx="2">
-            <a:schemeClr val="accent1"/>
-          </a:effectRef>
-          <a:fontRef idx="minor">
-            <a:schemeClr val="lt1"/>
-          </a:fontRef>
-        </p:style>
-        <p:txBody>
-          <a:bodyPr rtlCol="0" anchor="ctr"/>
-          <a:lstStyle/>
-          <a:p>
-            <a:pPr algn="ctr"/>
-          </a:p>
-        </p:txBody>
-      </p:sp>
-      <p:sp>
-        <p:nvSpPr>
-          <p:cNvPr id="3" name="TextBox 2"/>
-          <p:cNvSpPr txBox="1"/>
-          <p:nvPr/>
-        </p:nvSpPr>
-        <p:spPr>
-          <a:xfrm>
-            <a:off x="457200" y="182880"/>
-            <a:ext cx="8229600" cy="548640"/>
+            <a:off x="457200" y="457200"/>
+            <a:ext cx="8229600" cy="731520"/>
           </a:xfrm>
           <a:prstGeom prst="rect">
             <a:avLst/>
@@ -4248,26 +3936,26 @@
             <a:pPr>
               <a:defRPr sz="3200" b="1">
                 <a:solidFill>
-                  <a:srgbClr val="FFFFFF"/>
+                  <a:srgbClr val="003366"/>
                 </a:solidFill>
               </a:defRPr>
             </a:pPr>
             <a:r>
-              <a:t>02 AI在智慧城市中的主要应用场景（1/2）</a:t>
-            </a:r>
-          </a:p>
-        </p:txBody>
-      </p:sp>
-      <p:sp>
-        <p:nvSpPr>
-          <p:cNvPr id="4" name="TextBox 3"/>
+              <a:t>2. AI在智慧城市中的主要应用场景（上）</a:t>
+            </a:r>
+          </a:p>
+        </p:txBody>
+      </p:sp>
+      <p:sp>
+        <p:nvSpPr>
+          <p:cNvPr id="3" name="TextBox 2"/>
           <p:cNvSpPr txBox="1"/>
           <p:nvPr/>
         </p:nvSpPr>
         <p:spPr>
           <a:xfrm>
             <a:off x="731520" y="1371600"/>
-            <a:ext cx="7680960" cy="5029200"/>
+            <a:ext cx="7772400" cy="5029200"/>
           </a:xfrm>
           <a:prstGeom prst="rect">
             <a:avLst/>
@@ -4284,203 +3972,95 @@
               <a:spcBef>
                 <a:spcPts val="1200"/>
               </a:spcBef>
-              <a:defRPr sz="1800">
-                <a:solidFill>
-                  <a:srgbClr val="323232"/>
-                </a:solidFill>
-              </a:defRPr>
-            </a:pPr>
-            <a:r>
-              <a:t>智能交通管理</a:t>
-            </a:r>
-          </a:p>
-          <a:p>
-            <a:pPr>
-              <a:spcBef>
-                <a:spcPts val="1200"/>
-              </a:spcBef>
-              <a:defRPr sz="1800">
-                <a:solidFill>
-                  <a:srgbClr val="323232"/>
-                </a:solidFill>
-              </a:defRPr>
-            </a:pPr>
-            <a:r>
-              <a:t>   AI交通系统有效缓解道路拥堵</a:t>
-            </a:r>
-          </a:p>
-          <a:p>
-            <a:pPr>
-              <a:spcBef>
-                <a:spcPts val="1200"/>
-              </a:spcBef>
-              <a:defRPr sz="1800">
-                <a:solidFill>
-                  <a:srgbClr val="323232"/>
-                </a:solidFill>
-              </a:defRPr>
-            </a:pPr>
-            <a:r>
-              <a:t>   动态信号优化系统提升区域平均通行效率超过15%</a:t>
-            </a:r>
-          </a:p>
-          <a:p>
-            <a:pPr>
-              <a:spcBef>
-                <a:spcPts val="1200"/>
-              </a:spcBef>
-              <a:defRPr sz="1800">
-                <a:solidFill>
-                  <a:srgbClr val="323232"/>
-                </a:solidFill>
-              </a:defRPr>
-            </a:pPr>
-            <a:r>
-              <a:t>   实时路况预测和智能导航</a:t>
-            </a:r>
-          </a:p>
-          <a:p>
-            <a:pPr>
-              <a:spcBef>
-                <a:spcPts val="1200"/>
-              </a:spcBef>
-              <a:defRPr sz="1800">
-                <a:solidFill>
-                  <a:srgbClr val="323232"/>
-                </a:solidFill>
-              </a:defRPr>
-            </a:pPr>
-          </a:p>
-          <a:p>
-            <a:pPr>
-              <a:spcBef>
-                <a:spcPts val="1200"/>
-              </a:spcBef>
-              <a:defRPr sz="1800">
-                <a:solidFill>
-                  <a:srgbClr val="323232"/>
-                </a:solidFill>
-              </a:defRPr>
-            </a:pPr>
-            <a:r>
-              <a:t>智能安防监控</a:t>
-            </a:r>
-          </a:p>
-          <a:p>
-            <a:pPr>
-              <a:spcBef>
-                <a:spcPts val="1200"/>
-              </a:spcBef>
-              <a:defRPr sz="1800">
-                <a:solidFill>
-                  <a:srgbClr val="323232"/>
-                </a:solidFill>
-              </a:defRPr>
-            </a:pPr>
-            <a:r>
-              <a:t>   预测性安防系统在事故发生前及时预警</a:t>
-            </a:r>
-          </a:p>
-          <a:p>
-            <a:pPr>
-              <a:spcBef>
-                <a:spcPts val="1200"/>
-              </a:spcBef>
-              <a:defRPr sz="1800">
-                <a:solidFill>
-                  <a:srgbClr val="323232"/>
-                </a:solidFill>
-              </a:defRPr>
-            </a:pPr>
-            <a:r>
-              <a:t>   智能视频分析和人脸识别技术</a:t>
-            </a:r>
-          </a:p>
-          <a:p>
-            <a:pPr>
-              <a:spcBef>
-                <a:spcPts val="1200"/>
-              </a:spcBef>
-              <a:defRPr sz="1800">
-                <a:solidFill>
-                  <a:srgbClr val="323232"/>
-                </a:solidFill>
-              </a:defRPr>
-            </a:pPr>
-            <a:r>
-              <a:t>   香港锐眼计划：2028年达到60,000支智能摄像头覆盖</a:t>
-            </a:r>
-          </a:p>
-          <a:p>
-            <a:pPr>
-              <a:spcBef>
-                <a:spcPts val="1200"/>
-              </a:spcBef>
-              <a:defRPr sz="1800">
-                <a:solidFill>
-                  <a:srgbClr val="323232"/>
-                </a:solidFill>
-              </a:defRPr>
-            </a:pPr>
-          </a:p>
-          <a:p>
-            <a:pPr>
-              <a:spcBef>
-                <a:spcPts val="1200"/>
-              </a:spcBef>
-              <a:defRPr sz="1800">
-                <a:solidFill>
-                  <a:srgbClr val="323232"/>
-                </a:solidFill>
-              </a:defRPr>
-            </a:pPr>
-            <a:r>
-              <a:t>智能能源管理</a:t>
-            </a:r>
-          </a:p>
-          <a:p>
-            <a:pPr>
-              <a:spcBef>
-                <a:spcPts val="1200"/>
-              </a:spcBef>
-              <a:defRPr sz="1800">
-                <a:solidFill>
-                  <a:srgbClr val="323232"/>
-                </a:solidFill>
-              </a:defRPr>
-            </a:pPr>
-            <a:r>
-              <a:t>   AI调度将电网的波动性可再生能源消纳能力提升10%以上</a:t>
-            </a:r>
-          </a:p>
-          <a:p>
-            <a:pPr>
-              <a:spcBef>
-                <a:spcPts val="1200"/>
-              </a:spcBef>
-              <a:defRPr sz="1800">
-                <a:solidFill>
-                  <a:srgbClr val="323232"/>
-                </a:solidFill>
-              </a:defRPr>
-            </a:pPr>
-            <a:r>
-              <a:t>   实时监测和调整能源使用，减少浪费</a:t>
-            </a:r>
-          </a:p>
-          <a:p>
-            <a:pPr>
-              <a:spcBef>
-                <a:spcPts val="1200"/>
-              </a:spcBef>
-              <a:defRPr sz="1800">
-                <a:solidFill>
-                  <a:srgbClr val="323232"/>
-                </a:solidFill>
-              </a:defRPr>
-            </a:pPr>
-            <a:r>
-              <a:t>   智能电网和分布式能源管理</a:t>
+              <a:defRPr sz="1800"/>
+            </a:pPr>
+            <a:r>
+              <a:t>• 智能交通管理</a:t>
+            </a:r>
+          </a:p>
+          <a:p>
+            <a:pPr>
+              <a:spcBef>
+                <a:spcPts val="1200"/>
+              </a:spcBef>
+              <a:defRPr sz="1800"/>
+            </a:pPr>
+            <a:r>
+              <a:t>  - AI交通系统减少拥堵25%</a:t>
+            </a:r>
+          </a:p>
+          <a:p>
+            <a:pPr>
+              <a:spcBef>
+                <a:spcPts val="1200"/>
+              </a:spcBef>
+              <a:defRPr sz="1800"/>
+            </a:pPr>
+            <a:r>
+              <a:t>  - 自动驾驶与智能信号灯协同</a:t>
+            </a:r>
+          </a:p>
+          <a:p>
+            <a:pPr>
+              <a:spcBef>
+                <a:spcPts val="1200"/>
+              </a:spcBef>
+              <a:defRPr sz="1800"/>
+            </a:pPr>
+            <a:r>
+              <a:t>  - 实时路况预测与优化</a:t>
+            </a:r>
+          </a:p>
+          <a:p>
+            <a:pPr>
+              <a:spcBef>
+                <a:spcPts val="1200"/>
+              </a:spcBef>
+              <a:defRPr sz="1800"/>
+            </a:pPr>
+          </a:p>
+          <a:p>
+            <a:pPr>
+              <a:spcBef>
+                <a:spcPts val="1200"/>
+              </a:spcBef>
+              <a:defRPr sz="1800"/>
+            </a:pPr>
+            <a:r>
+              <a:t>• 智慧能源管理</a:t>
+            </a:r>
+          </a:p>
+          <a:p>
+            <a:pPr>
+              <a:spcBef>
+                <a:spcPts val="1200"/>
+              </a:spcBef>
+              <a:defRPr sz="1800"/>
+            </a:pPr>
+            <a:r>
+              <a:t>  - 虚拟电厂提供100MW备用电力</a:t>
+            </a:r>
+          </a:p>
+          <a:p>
+            <a:pPr>
+              <a:spcBef>
+                <a:spcPts val="1200"/>
+              </a:spcBef>
+              <a:defRPr sz="1800"/>
+            </a:pPr>
+            <a:r>
+              <a:t>  - AI优化能源分配，降低消耗</a:t>
+            </a:r>
+          </a:p>
+          <a:p>
+            <a:pPr>
+              <a:spcBef>
+                <a:spcPts val="1200"/>
+              </a:spcBef>
+              <a:defRPr sz="1800"/>
+            </a:pPr>
+            <a:r>
+              <a:t>  - 智能电网实时监控与调度</a:t>
             </a:r>
           </a:p>
         </p:txBody>
@@ -4505,59 +4085,14 @@
       <p:grpSpPr/>
       <p:sp>
         <p:nvSpPr>
-          <p:cNvPr id="2" name="Rectangle 1"/>
-          <p:cNvSpPr/>
+          <p:cNvPr id="2" name="TextBox 1"/>
+          <p:cNvSpPr txBox="1"/>
           <p:nvPr/>
         </p:nvSpPr>
         <p:spPr>
           <a:xfrm>
-            <a:off x="0" y="0"/>
-            <a:ext cx="9144000" cy="914400"/>
-          </a:xfrm>
-          <a:prstGeom prst="rect">
-            <a:avLst/>
-          </a:prstGeom>
-          <a:solidFill>
-            <a:srgbClr val="0F4C81"/>
-          </a:solidFill>
-          <a:ln>
-            <a:solidFill>
-              <a:srgbClr val="0F4C81"/>
-            </a:solidFill>
-          </a:ln>
-        </p:spPr>
-        <p:style>
-          <a:lnRef idx="1">
-            <a:schemeClr val="accent1"/>
-          </a:lnRef>
-          <a:fillRef idx="3">
-            <a:schemeClr val="accent1"/>
-          </a:fillRef>
-          <a:effectRef idx="2">
-            <a:schemeClr val="accent1"/>
-          </a:effectRef>
-          <a:fontRef idx="minor">
-            <a:schemeClr val="lt1"/>
-          </a:fontRef>
-        </p:style>
-        <p:txBody>
-          <a:bodyPr rtlCol="0" anchor="ctr"/>
-          <a:lstStyle/>
-          <a:p>
-            <a:pPr algn="ctr"/>
-          </a:p>
-        </p:txBody>
-      </p:sp>
-      <p:sp>
-        <p:nvSpPr>
-          <p:cNvPr id="3" name="TextBox 2"/>
-          <p:cNvSpPr txBox="1"/>
-          <p:nvPr/>
-        </p:nvSpPr>
-        <p:spPr>
-          <a:xfrm>
-            <a:off x="457200" y="182880"/>
-            <a:ext cx="8229600" cy="548640"/>
+            <a:off x="457200" y="457200"/>
+            <a:ext cx="8229600" cy="731520"/>
           </a:xfrm>
           <a:prstGeom prst="rect">
             <a:avLst/>
@@ -4573,26 +4108,26 @@
             <a:pPr>
               <a:defRPr sz="3200" b="1">
                 <a:solidFill>
-                  <a:srgbClr val="FFFFFF"/>
+                  <a:srgbClr val="003366"/>
                 </a:solidFill>
               </a:defRPr>
             </a:pPr>
             <a:r>
-              <a:t>02 AI在智慧城市中的主要应用场景（2/2）</a:t>
-            </a:r>
-          </a:p>
-        </p:txBody>
-      </p:sp>
-      <p:sp>
-        <p:nvSpPr>
-          <p:cNvPr id="4" name="TextBox 3"/>
+              <a:t>2. AI在智慧城市中的主要应用场景（下）</a:t>
+            </a:r>
+          </a:p>
+        </p:txBody>
+      </p:sp>
+      <p:sp>
+        <p:nvSpPr>
+          <p:cNvPr id="3" name="TextBox 2"/>
           <p:cNvSpPr txBox="1"/>
           <p:nvPr/>
         </p:nvSpPr>
         <p:spPr>
           <a:xfrm>
             <a:off x="731520" y="1371600"/>
-            <a:ext cx="7680960" cy="5029200"/>
+            <a:ext cx="7772400" cy="5029200"/>
           </a:xfrm>
           <a:prstGeom prst="rect">
             <a:avLst/>
@@ -4609,203 +4144,95 @@
               <a:spcBef>
                 <a:spcPts val="1200"/>
               </a:spcBef>
-              <a:defRPr sz="1800">
-                <a:solidFill>
-                  <a:srgbClr val="323232"/>
-                </a:solidFill>
-              </a:defRPr>
-            </a:pPr>
-            <a:r>
-              <a:t>城市治理优化</a:t>
-            </a:r>
-          </a:p>
-          <a:p>
-            <a:pPr>
-              <a:spcBef>
-                <a:spcPts val="1200"/>
-              </a:spcBef>
-              <a:defRPr sz="1800">
-                <a:solidFill>
-                  <a:srgbClr val="323232"/>
-                </a:solidFill>
-              </a:defRPr>
-            </a:pPr>
-            <a:r>
-              <a:t>   物联网垃圾箱在将满时自动发出清运提醒</a:t>
-            </a:r>
-          </a:p>
-          <a:p>
-            <a:pPr>
-              <a:spcBef>
-                <a:spcPts val="1200"/>
-              </a:spcBef>
-              <a:defRPr sz="1800">
-                <a:solidFill>
-                  <a:srgbClr val="323232"/>
-                </a:solidFill>
-              </a:defRPr>
-            </a:pPr>
-            <a:r>
-              <a:t>   智能街灯根据行人数量自动调节亮度</a:t>
-            </a:r>
-          </a:p>
-          <a:p>
-            <a:pPr>
-              <a:spcBef>
-                <a:spcPts val="1200"/>
-              </a:spcBef>
-              <a:defRPr sz="1800">
-                <a:solidFill>
-                  <a:srgbClr val="323232"/>
-                </a:solidFill>
-              </a:defRPr>
-            </a:pPr>
-            <a:r>
-              <a:t>   数据要素流通实现跨部门创新成果增长50%（预计2026年）</a:t>
-            </a:r>
-          </a:p>
-          <a:p>
-            <a:pPr>
-              <a:spcBef>
-                <a:spcPts val="1200"/>
-              </a:spcBef>
-              <a:defRPr sz="1800">
-                <a:solidFill>
-                  <a:srgbClr val="323232"/>
-                </a:solidFill>
-              </a:defRPr>
-            </a:pPr>
-          </a:p>
-          <a:p>
-            <a:pPr>
-              <a:spcBef>
-                <a:spcPts val="1200"/>
-              </a:spcBef>
-              <a:defRPr sz="1800">
-                <a:solidFill>
-                  <a:srgbClr val="323232"/>
-                </a:solidFill>
-              </a:defRPr>
-            </a:pPr>
-            <a:r>
-              <a:t>公共服务提升</a:t>
-            </a:r>
-          </a:p>
-          <a:p>
-            <a:pPr>
-              <a:spcBef>
-                <a:spcPts val="1200"/>
-              </a:spcBef>
-              <a:defRPr sz="1800">
-                <a:solidFill>
-                  <a:srgbClr val="323232"/>
-                </a:solidFill>
-              </a:defRPr>
-            </a:pPr>
-            <a:r>
-              <a:t>   AI辅助医疗诊断和健康管理</a:t>
-            </a:r>
-          </a:p>
-          <a:p>
-            <a:pPr>
-              <a:spcBef>
-                <a:spcPts val="1200"/>
-              </a:spcBef>
-              <a:defRPr sz="1800">
-                <a:solidFill>
-                  <a:srgbClr val="323232"/>
-                </a:solidFill>
-              </a:defRPr>
-            </a:pPr>
-            <a:r>
-              <a:t>   智能教育平台和个性化学习</a:t>
-            </a:r>
-          </a:p>
-          <a:p>
-            <a:pPr>
-              <a:spcBef>
-                <a:spcPts val="1200"/>
-              </a:spcBef>
-              <a:defRPr sz="1800">
-                <a:solidFill>
-                  <a:srgbClr val="323232"/>
-                </a:solidFill>
-              </a:defRPr>
-            </a:pPr>
-            <a:r>
-              <a:t>   数字政府服务和一站式办事平台</a:t>
-            </a:r>
-          </a:p>
-          <a:p>
-            <a:pPr>
-              <a:spcBef>
-                <a:spcPts val="1200"/>
-              </a:spcBef>
-              <a:defRPr sz="1800">
-                <a:solidFill>
-                  <a:srgbClr val="323232"/>
-                </a:solidFill>
-              </a:defRPr>
-            </a:pPr>
-          </a:p>
-          <a:p>
-            <a:pPr>
-              <a:spcBef>
-                <a:spcPts val="1200"/>
-              </a:spcBef>
-              <a:defRPr sz="1800">
-                <a:solidFill>
-                  <a:srgbClr val="323232"/>
-                </a:solidFill>
-              </a:defRPr>
-            </a:pPr>
-            <a:r>
-              <a:t>环境监测与保护</a:t>
-            </a:r>
-          </a:p>
-          <a:p>
-            <a:pPr>
-              <a:spcBef>
-                <a:spcPts val="1200"/>
-              </a:spcBef>
-              <a:defRPr sz="1800">
-                <a:solidFill>
-                  <a:srgbClr val="323232"/>
-                </a:solidFill>
-              </a:defRPr>
-            </a:pPr>
-            <a:r>
-              <a:t>   空气质量实时监测和预警</a:t>
-            </a:r>
-          </a:p>
-          <a:p>
-            <a:pPr>
-              <a:spcBef>
-                <a:spcPts val="1200"/>
-              </a:spcBef>
-              <a:defRPr sz="1800">
-                <a:solidFill>
-                  <a:srgbClr val="323232"/>
-                </a:solidFill>
-              </a:defRPr>
-            </a:pPr>
-            <a:r>
-              <a:t>   水资源智能管理，消耗量降低超20%</a:t>
-            </a:r>
-          </a:p>
-          <a:p>
-            <a:pPr>
-              <a:spcBef>
-                <a:spcPts val="1200"/>
-              </a:spcBef>
-              <a:defRPr sz="1800">
-                <a:solidFill>
-                  <a:srgbClr val="323232"/>
-                </a:solidFill>
-              </a:defRPr>
-            </a:pPr>
-            <a:r>
-              <a:t>   城市绿色低碳发展支持</a:t>
+              <a:defRPr sz="1800"/>
+            </a:pPr>
+            <a:r>
+              <a:t>• 城市治理与公共安全</a:t>
+            </a:r>
+          </a:p>
+          <a:p>
+            <a:pPr>
+              <a:spcBef>
+                <a:spcPts val="1200"/>
+              </a:spcBef>
+              <a:defRPr sz="1800"/>
+            </a:pPr>
+            <a:r>
+              <a:t>  - AI视觉监控与异常检测</a:t>
+            </a:r>
+          </a:p>
+          <a:p>
+            <a:pPr>
+              <a:spcBef>
+                <a:spcPts val="1200"/>
+              </a:spcBef>
+              <a:defRPr sz="1800"/>
+            </a:pPr>
+            <a:r>
+              <a:t>  - 智能应急响应系统</a:t>
+            </a:r>
+          </a:p>
+          <a:p>
+            <a:pPr>
+              <a:spcBef>
+                <a:spcPts val="1200"/>
+              </a:spcBef>
+              <a:defRPr sz="1800"/>
+            </a:pPr>
+            <a:r>
+              <a:t>  - 公共数据流通与利用</a:t>
+            </a:r>
+          </a:p>
+          <a:p>
+            <a:pPr>
+              <a:spcBef>
+                <a:spcPts val="1200"/>
+              </a:spcBef>
+              <a:defRPr sz="1800"/>
+            </a:pPr>
+          </a:p>
+          <a:p>
+            <a:pPr>
+              <a:spcBef>
+                <a:spcPts val="1200"/>
+              </a:spcBef>
+              <a:defRPr sz="1800"/>
+            </a:pPr>
+            <a:r>
+              <a:t>• 智慧民生服务</a:t>
+            </a:r>
+          </a:p>
+          <a:p>
+            <a:pPr>
+              <a:spcBef>
+                <a:spcPts val="1200"/>
+              </a:spcBef>
+              <a:defRPr sz="1800"/>
+            </a:pPr>
+            <a:r>
+              <a:t>  - IoT废物管理网络减少卡车运行90%</a:t>
+            </a:r>
+          </a:p>
+          <a:p>
+            <a:pPr>
+              <a:spcBef>
+                <a:spcPts val="1200"/>
+              </a:spcBef>
+              <a:defRPr sz="1800"/>
+            </a:pPr>
+            <a:r>
+              <a:t>  - AI政务服务（公文处理、审核自动化）</a:t>
+            </a:r>
+          </a:p>
+          <a:p>
+            <a:pPr>
+              <a:spcBef>
+                <a:spcPts val="1200"/>
+              </a:spcBef>
+              <a:defRPr sz="1800"/>
+            </a:pPr>
+            <a:r>
+              <a:t>  - 智能医疗与健康监测</a:t>
             </a:r>
           </a:p>
         </p:txBody>
@@ -4830,59 +4257,14 @@
       <p:grpSpPr/>
       <p:sp>
         <p:nvSpPr>
-          <p:cNvPr id="2" name="Rectangle 1"/>
-          <p:cNvSpPr/>
+          <p:cNvPr id="2" name="TextBox 1"/>
+          <p:cNvSpPr txBox="1"/>
           <p:nvPr/>
         </p:nvSpPr>
         <p:spPr>
           <a:xfrm>
-            <a:off x="0" y="0"/>
-            <a:ext cx="9144000" cy="914400"/>
-          </a:xfrm>
-          <a:prstGeom prst="rect">
-            <a:avLst/>
-          </a:prstGeom>
-          <a:solidFill>
-            <a:srgbClr val="0F4C81"/>
-          </a:solidFill>
-          <a:ln>
-            <a:solidFill>
-              <a:srgbClr val="0F4C81"/>
-            </a:solidFill>
-          </a:ln>
-        </p:spPr>
-        <p:style>
-          <a:lnRef idx="1">
-            <a:schemeClr val="accent1"/>
-          </a:lnRef>
-          <a:fillRef idx="3">
-            <a:schemeClr val="accent1"/>
-          </a:fillRef>
-          <a:effectRef idx="2">
-            <a:schemeClr val="accent1"/>
-          </a:effectRef>
-          <a:fontRef idx="minor">
-            <a:schemeClr val="lt1"/>
-          </a:fontRef>
-        </p:style>
-        <p:txBody>
-          <a:bodyPr rtlCol="0" anchor="ctr"/>
-          <a:lstStyle/>
-          <a:p>
-            <a:pPr algn="ctr"/>
-          </a:p>
-        </p:txBody>
-      </p:sp>
-      <p:sp>
-        <p:nvSpPr>
-          <p:cNvPr id="3" name="TextBox 2"/>
-          <p:cNvSpPr txBox="1"/>
-          <p:nvPr/>
-        </p:nvSpPr>
-        <p:spPr>
-          <a:xfrm>
-            <a:off x="457200" y="182880"/>
-            <a:ext cx="8229600" cy="548640"/>
+            <a:off x="457200" y="457200"/>
+            <a:ext cx="8229600" cy="731520"/>
           </a:xfrm>
           <a:prstGeom prst="rect">
             <a:avLst/>
@@ -4898,26 +4280,26 @@
             <a:pPr>
               <a:defRPr sz="3200" b="1">
                 <a:solidFill>
-                  <a:srgbClr val="FFFFFF"/>
+                  <a:srgbClr val="003366"/>
                 </a:solidFill>
               </a:defRPr>
             </a:pPr>
             <a:r>
-              <a:t>03 2026年最新技术和趋势（1/2）</a:t>
-            </a:r>
-          </a:p>
-        </p:txBody>
-      </p:sp>
-      <p:sp>
-        <p:nvSpPr>
-          <p:cNvPr id="4" name="TextBox 3"/>
+              <a:t>3. 2026年最新技术和趋势（上）</a:t>
+            </a:r>
+          </a:p>
+        </p:txBody>
+      </p:sp>
+      <p:sp>
+        <p:nvSpPr>
+          <p:cNvPr id="3" name="TextBox 2"/>
           <p:cNvSpPr txBox="1"/>
           <p:nvPr/>
         </p:nvSpPr>
         <p:spPr>
           <a:xfrm>
             <a:off x="731520" y="1371600"/>
-            <a:ext cx="7680960" cy="5029200"/>
+            <a:ext cx="7772400" cy="5029200"/>
           </a:xfrm>
           <a:prstGeom prst="rect">
             <a:avLst/>
@@ -4934,203 +4316,95 @@
               <a:spcBef>
                 <a:spcPts val="1200"/>
               </a:spcBef>
-              <a:defRPr sz="1800">
-                <a:solidFill>
-                  <a:srgbClr val="323232"/>
-                </a:solidFill>
-              </a:defRPr>
-            </a:pPr>
-            <a:r>
-              <a:t>Agentic AI与生成式AI</a:t>
-            </a:r>
-          </a:p>
-          <a:p>
-            <a:pPr>
-              <a:spcBef>
-                <a:spcPts val="1200"/>
-              </a:spcBef>
-              <a:defRPr sz="1800">
-                <a:solidFill>
-                  <a:srgbClr val="323232"/>
-                </a:solidFill>
-              </a:defRPr>
-            </a:pPr>
-            <a:r>
-              <a:t>   Agentic AI重塑城市系统，实现自主决策和执行</a:t>
-            </a:r>
-          </a:p>
-          <a:p>
-            <a:pPr>
-              <a:spcBef>
-                <a:spcPts val="1200"/>
-              </a:spcBef>
-              <a:defRPr sz="1800">
-                <a:solidFill>
-                  <a:srgbClr val="323232"/>
-                </a:solidFill>
-              </a:defRPr>
-            </a:pPr>
-            <a:r>
-              <a:t>   生成式AI解锁政府数据，提供智能分析和预测</a:t>
-            </a:r>
-          </a:p>
-          <a:p>
-            <a:pPr>
-              <a:spcBef>
-                <a:spcPts val="1200"/>
-              </a:spcBef>
-              <a:defRPr sz="1800">
-                <a:solidFill>
-                  <a:srgbClr val="323232"/>
-                </a:solidFill>
-              </a:defRPr>
-            </a:pPr>
-            <a:r>
-              <a:t>   AI成为城市的中枢神经系统</a:t>
-            </a:r>
-          </a:p>
-          <a:p>
-            <a:pPr>
-              <a:spcBef>
-                <a:spcPts val="1200"/>
-              </a:spcBef>
-              <a:defRPr sz="1800">
-                <a:solidFill>
-                  <a:srgbClr val="323232"/>
-                </a:solidFill>
-              </a:defRPr>
-            </a:pPr>
-          </a:p>
-          <a:p>
-            <a:pPr>
-              <a:spcBef>
-                <a:spcPts val="1200"/>
-              </a:spcBef>
-              <a:defRPr sz="1800">
-                <a:solidFill>
-                  <a:srgbClr val="323232"/>
-                </a:solidFill>
-              </a:defRPr>
-            </a:pPr>
-            <a:r>
-              <a:t>5G/6G网络与物联网</a:t>
-            </a:r>
-          </a:p>
-          <a:p>
-            <a:pPr>
-              <a:spcBef>
-                <a:spcPts val="1200"/>
-              </a:spcBef>
-              <a:defRPr sz="1800">
-                <a:solidFill>
-                  <a:srgbClr val="323232"/>
-                </a:solidFill>
-              </a:defRPr>
-            </a:pPr>
-            <a:r>
-              <a:t>   全球IoT市场在智慧城市领域：2021年3000亿美元 -&gt; 2026年6500亿美元</a:t>
-            </a:r>
-          </a:p>
-          <a:p>
-            <a:pPr>
-              <a:spcBef>
-                <a:spcPts val="1200"/>
-              </a:spcBef>
-              <a:defRPr sz="1800">
-                <a:solidFill>
-                  <a:srgbClr val="323232"/>
-                </a:solidFill>
-              </a:defRPr>
-            </a:pPr>
-            <a:r>
-              <a:t>   超高速、低延迟网络支持实时数据传输</a:t>
-            </a:r>
-          </a:p>
-          <a:p>
-            <a:pPr>
-              <a:spcBef>
-                <a:spcPts val="1200"/>
-              </a:spcBef>
-              <a:defRPr sz="1800">
-                <a:solidFill>
-                  <a:srgbClr val="323232"/>
-                </a:solidFill>
-              </a:defRPr>
-            </a:pPr>
-            <a:r>
-              <a:t>   万物互联实现城市全域感知</a:t>
-            </a:r>
-          </a:p>
-          <a:p>
-            <a:pPr>
-              <a:spcBef>
-                <a:spcPts val="1200"/>
-              </a:spcBef>
-              <a:defRPr sz="1800">
-                <a:solidFill>
-                  <a:srgbClr val="323232"/>
-                </a:solidFill>
-              </a:defRPr>
-            </a:pPr>
-          </a:p>
-          <a:p>
-            <a:pPr>
-              <a:spcBef>
-                <a:spcPts val="1200"/>
-              </a:spcBef>
-              <a:defRPr sz="1800">
-                <a:solidFill>
-                  <a:srgbClr val="323232"/>
-                </a:solidFill>
-              </a:defRPr>
-            </a:pPr>
-            <a:r>
-              <a:t>数字孪生技术</a:t>
-            </a:r>
-          </a:p>
-          <a:p>
-            <a:pPr>
-              <a:spcBef>
-                <a:spcPts val="1200"/>
-              </a:spcBef>
-              <a:defRPr sz="1800">
-                <a:solidFill>
-                  <a:srgbClr val="323232"/>
-                </a:solidFill>
-              </a:defRPr>
-            </a:pPr>
-            <a:r>
-              <a:t>   创建城市的虚拟副本，进行模拟和优化</a:t>
-            </a:r>
-          </a:p>
-          <a:p>
-            <a:pPr>
-              <a:spcBef>
-                <a:spcPts val="1200"/>
-              </a:spcBef>
-              <a:defRPr sz="1800">
-                <a:solidFill>
-                  <a:srgbClr val="323232"/>
-                </a:solidFill>
-              </a:defRPr>
-            </a:pPr>
-            <a:r>
-              <a:t>   实时数据同步，支持预测性维护</a:t>
-            </a:r>
-          </a:p>
-          <a:p>
-            <a:pPr>
-              <a:spcBef>
-                <a:spcPts val="1200"/>
-              </a:spcBef>
-              <a:defRPr sz="1800">
-                <a:solidFill>
-                  <a:srgbClr val="323232"/>
-                </a:solidFill>
-              </a:defRPr>
-            </a:pPr>
-            <a:r>
-              <a:t>   CityOS统一数字平台整合城市运营</a:t>
+              <a:defRPr sz="1800"/>
+            </a:pPr>
+            <a:r>
+              <a:t>• Agentic AI（智能体AI）</a:t>
+            </a:r>
+          </a:p>
+          <a:p>
+            <a:pPr>
+              <a:spcBef>
+                <a:spcPts val="1200"/>
+              </a:spcBef>
+              <a:defRPr sz="1800"/>
+            </a:pPr>
+            <a:r>
+              <a:t>  - 到2027年，中国70%的城市将部署AI智能体</a:t>
+            </a:r>
+          </a:p>
+          <a:p>
+            <a:pPr>
+              <a:spcBef>
+                <a:spcPts val="1200"/>
+              </a:spcBef>
+              <a:defRPr sz="1800"/>
+            </a:pPr>
+            <a:r>
+              <a:t>  - 协同端到端工作流程，减轻工作量</a:t>
+            </a:r>
+          </a:p>
+          <a:p>
+            <a:pPr>
+              <a:spcBef>
+                <a:spcPts val="1200"/>
+              </a:spcBef>
+              <a:defRPr sz="1800"/>
+            </a:pPr>
+            <a:r>
+              <a:t>  - 自主决策与跨系统协作</a:t>
+            </a:r>
+          </a:p>
+          <a:p>
+            <a:pPr>
+              <a:spcBef>
+                <a:spcPts val="1200"/>
+              </a:spcBef>
+              <a:defRPr sz="1800"/>
+            </a:pPr>
+          </a:p>
+          <a:p>
+            <a:pPr>
+              <a:spcBef>
+                <a:spcPts val="1200"/>
+              </a:spcBef>
+              <a:defRPr sz="1800"/>
+            </a:pPr>
+            <a:r>
+              <a:t>• 生成式AI（GenAI）</a:t>
+            </a:r>
+          </a:p>
+          <a:p>
+            <a:pPr>
+              <a:spcBef>
+                <a:spcPts val="1200"/>
+              </a:spcBef>
+              <a:defRPr sz="1800"/>
+            </a:pPr>
+            <a:r>
+              <a:t>  - 解锁数十年隐藏的政府数据</a:t>
+            </a:r>
+          </a:p>
+          <a:p>
+            <a:pPr>
+              <a:spcBef>
+                <a:spcPts val="1200"/>
+              </a:spcBef>
+              <a:defRPr sz="1800"/>
+            </a:pPr>
+            <a:r>
+              <a:t>  - 自动化文档处理与知识提取</a:t>
+            </a:r>
+          </a:p>
+          <a:p>
+            <a:pPr>
+              <a:spcBef>
+                <a:spcPts val="1200"/>
+              </a:spcBef>
+              <a:defRPr sz="1800"/>
+            </a:pPr>
+            <a:r>
+              <a:t>  - 精细调优的大语言模型（LLM）应用</a:t>
             </a:r>
           </a:p>
         </p:txBody>
@@ -5155,59 +4429,14 @@
       <p:grpSpPr/>
       <p:sp>
         <p:nvSpPr>
-          <p:cNvPr id="2" name="Rectangle 1"/>
-          <p:cNvSpPr/>
+          <p:cNvPr id="2" name="TextBox 1"/>
+          <p:cNvSpPr txBox="1"/>
           <p:nvPr/>
         </p:nvSpPr>
         <p:spPr>
           <a:xfrm>
-            <a:off x="0" y="0"/>
-            <a:ext cx="9144000" cy="914400"/>
-          </a:xfrm>
-          <a:prstGeom prst="rect">
-            <a:avLst/>
-          </a:prstGeom>
-          <a:solidFill>
-            <a:srgbClr val="0F4C81"/>
-          </a:solidFill>
-          <a:ln>
-            <a:solidFill>
-              <a:srgbClr val="0F4C81"/>
-            </a:solidFill>
-          </a:ln>
-        </p:spPr>
-        <p:style>
-          <a:lnRef idx="1">
-            <a:schemeClr val="accent1"/>
-          </a:lnRef>
-          <a:fillRef idx="3">
-            <a:schemeClr val="accent1"/>
-          </a:fillRef>
-          <a:effectRef idx="2">
-            <a:schemeClr val="accent1"/>
-          </a:effectRef>
-          <a:fontRef idx="minor">
-            <a:schemeClr val="lt1"/>
-          </a:fontRef>
-        </p:style>
-        <p:txBody>
-          <a:bodyPr rtlCol="0" anchor="ctr"/>
-          <a:lstStyle/>
-          <a:p>
-            <a:pPr algn="ctr"/>
-          </a:p>
-        </p:txBody>
-      </p:sp>
-      <p:sp>
-        <p:nvSpPr>
-          <p:cNvPr id="3" name="TextBox 2"/>
-          <p:cNvSpPr txBox="1"/>
-          <p:nvPr/>
-        </p:nvSpPr>
-        <p:spPr>
-          <a:xfrm>
-            <a:off x="457200" y="182880"/>
-            <a:ext cx="8229600" cy="548640"/>
+            <a:off x="457200" y="457200"/>
+            <a:ext cx="8229600" cy="731520"/>
           </a:xfrm>
           <a:prstGeom prst="rect">
             <a:avLst/>
@@ -5223,26 +4452,26 @@
             <a:pPr>
               <a:defRPr sz="3200" b="1">
                 <a:solidFill>
-                  <a:srgbClr val="FFFFFF"/>
+                  <a:srgbClr val="003366"/>
                 </a:solidFill>
               </a:defRPr>
             </a:pPr>
             <a:r>
-              <a:t>03 2026年最新技术和趋势（2/2）</a:t>
-            </a:r>
-          </a:p>
-        </p:txBody>
-      </p:sp>
-      <p:sp>
-        <p:nvSpPr>
-          <p:cNvPr id="4" name="TextBox 3"/>
+              <a:t>3. 2026年最新技术和趋势（下）</a:t>
+            </a:r>
+          </a:p>
+        </p:txBody>
+      </p:sp>
+      <p:sp>
+        <p:nvSpPr>
+          <p:cNvPr id="3" name="TextBox 2"/>
           <p:cNvSpPr txBox="1"/>
           <p:nvPr/>
         </p:nvSpPr>
         <p:spPr>
           <a:xfrm>
             <a:off x="731520" y="1371600"/>
-            <a:ext cx="7680960" cy="5029200"/>
+            <a:ext cx="7772400" cy="5029200"/>
           </a:xfrm>
           <a:prstGeom prst="rect">
             <a:avLst/>
@@ -5259,203 +4488,95 @@
               <a:spcBef>
                 <a:spcPts val="1200"/>
               </a:spcBef>
-              <a:defRPr sz="1800">
-                <a:solidFill>
-                  <a:srgbClr val="323232"/>
-                </a:solidFill>
-              </a:defRPr>
-            </a:pPr>
-            <a:r>
-              <a:t>空中交通革命</a:t>
-            </a:r>
-          </a:p>
-          <a:p>
-            <a:pPr>
-              <a:spcBef>
-                <a:spcPts val="1200"/>
-              </a:spcBef>
-              <a:defRPr sz="1800">
-                <a:solidFill>
-                  <a:srgbClr val="323232"/>
-                </a:solidFill>
-              </a:defRPr>
-            </a:pPr>
-            <a:r>
-              <a:t>   空中出租车（Air Taxis）预计2026年投入商业运营</a:t>
-            </a:r>
-          </a:p>
-          <a:p>
-            <a:pPr>
-              <a:spcBef>
-                <a:spcPts val="1200"/>
-              </a:spcBef>
-              <a:defRPr sz="1800">
-                <a:solidFill>
-                  <a:srgbClr val="323232"/>
-                </a:solidFill>
-              </a:defRPr>
-            </a:pPr>
-            <a:r>
-              <a:t>   机器人出租车（Robotaxis）在更多城市街道上运行</a:t>
-            </a:r>
-          </a:p>
-          <a:p>
-            <a:pPr>
-              <a:spcBef>
-                <a:spcPts val="1200"/>
-              </a:spcBef>
-              <a:defRPr sz="1800">
-                <a:solidFill>
-                  <a:srgbClr val="323232"/>
-                </a:solidFill>
-              </a:defRPr>
-            </a:pPr>
-            <a:r>
-              <a:t>   立体交通网络缓解地面拥堵</a:t>
-            </a:r>
-          </a:p>
-          <a:p>
-            <a:pPr>
-              <a:spcBef>
-                <a:spcPts val="1200"/>
-              </a:spcBef>
-              <a:defRPr sz="1800">
-                <a:solidFill>
-                  <a:srgbClr val="323232"/>
-                </a:solidFill>
-              </a:defRPr>
-            </a:pPr>
-          </a:p>
-          <a:p>
-            <a:pPr>
-              <a:spcBef>
-                <a:spcPts val="1200"/>
-              </a:spcBef>
-              <a:defRPr sz="1800">
-                <a:solidFill>
-                  <a:srgbClr val="323232"/>
-                </a:solidFill>
-              </a:defRPr>
-            </a:pPr>
-            <a:r>
-              <a:t>可持续发展技术</a:t>
-            </a:r>
-          </a:p>
-          <a:p>
-            <a:pPr>
-              <a:spcBef>
-                <a:spcPts val="1200"/>
-              </a:spcBef>
-              <a:defRPr sz="1800">
-                <a:solidFill>
-                  <a:srgbClr val="323232"/>
-                </a:solidFill>
-              </a:defRPr>
-            </a:pPr>
-            <a:r>
-              <a:t>   搭载计算优化芯片的高感知能力基础设施</a:t>
-            </a:r>
-          </a:p>
-          <a:p>
-            <a:pPr>
-              <a:spcBef>
-                <a:spcPts val="1200"/>
-              </a:spcBef>
-              <a:defRPr sz="1800">
-                <a:solidFill>
-                  <a:srgbClr val="323232"/>
-                </a:solidFill>
-              </a:defRPr>
-            </a:pPr>
-            <a:r>
-              <a:t>   智能建筑和绿色能源整合</a:t>
-            </a:r>
-          </a:p>
-          <a:p>
-            <a:pPr>
-              <a:spcBef>
-                <a:spcPts val="1200"/>
-              </a:spcBef>
-              <a:defRPr sz="1800">
-                <a:solidFill>
-                  <a:srgbClr val="323232"/>
-                </a:solidFill>
-              </a:defRPr>
-            </a:pPr>
-            <a:r>
-              <a:t>   城市碳排放实时监测和管理</a:t>
-            </a:r>
-          </a:p>
-          <a:p>
-            <a:pPr>
-              <a:spcBef>
-                <a:spcPts val="1200"/>
-              </a:spcBef>
-              <a:defRPr sz="1800">
-                <a:solidFill>
-                  <a:srgbClr val="323232"/>
-                </a:solidFill>
-              </a:defRPr>
-            </a:pPr>
-          </a:p>
-          <a:p>
-            <a:pPr>
-              <a:spcBef>
-                <a:spcPts val="1200"/>
-              </a:spcBef>
-              <a:defRPr sz="1800">
-                <a:solidFill>
-                  <a:srgbClr val="323232"/>
-                </a:solidFill>
-              </a:defRPr>
-            </a:pPr>
-            <a:r>
-              <a:t>数据融合与智能分析</a:t>
-            </a:r>
-          </a:p>
-          <a:p>
-            <a:pPr>
-              <a:spcBef>
-                <a:spcPts val="1200"/>
-              </a:spcBef>
-              <a:defRPr sz="1800">
-                <a:solidFill>
-                  <a:srgbClr val="323232"/>
-                </a:solidFill>
-              </a:defRPr>
-            </a:pPr>
-            <a:r>
-              <a:t>   跨部门数据整合和共享</a:t>
-            </a:r>
-          </a:p>
-          <a:p>
-            <a:pPr>
-              <a:spcBef>
-                <a:spcPts val="1200"/>
-              </a:spcBef>
-              <a:defRPr sz="1800">
-                <a:solidFill>
-                  <a:srgbClr val="323232"/>
-                </a:solidFill>
-              </a:defRPr>
-            </a:pPr>
-            <a:r>
-              <a:t>   边缘计算提升实时处理能力</a:t>
-            </a:r>
-          </a:p>
-          <a:p>
-            <a:pPr>
-              <a:spcBef>
-                <a:spcPts val="1200"/>
-              </a:spcBef>
-              <a:defRPr sz="1800">
-                <a:solidFill>
-                  <a:srgbClr val="323232"/>
-                </a:solidFill>
-              </a:defRPr>
-            </a:pPr>
-            <a:r>
-              <a:t>   AI驱动的城市运营决策支持系统</a:t>
+              <a:defRPr sz="1800"/>
+            </a:pPr>
+            <a:r>
+              <a:t>• 边缘智能与IoT融合</a:t>
+            </a:r>
+          </a:p>
+          <a:p>
+            <a:pPr>
+              <a:spcBef>
+                <a:spcPts val="1200"/>
+              </a:spcBef>
+              <a:defRPr sz="1800"/>
+            </a:pPr>
+            <a:r>
+              <a:t>  - 边缘计算降低延迟，提升响应速度</a:t>
+            </a:r>
+          </a:p>
+          <a:p>
+            <a:pPr>
+              <a:spcBef>
+                <a:spcPts val="1200"/>
+              </a:spcBef>
+              <a:defRPr sz="1800"/>
+            </a:pPr>
+            <a:r>
+              <a:t>  - IoT设备与AI模型本地化部署</a:t>
+            </a:r>
+          </a:p>
+          <a:p>
+            <a:pPr>
+              <a:spcBef>
+                <a:spcPts val="1200"/>
+              </a:spcBef>
+              <a:defRPr sz="1800"/>
+            </a:pPr>
+            <a:r>
+              <a:t>  - 5G网络支撑海量设备连接</a:t>
+            </a:r>
+          </a:p>
+          <a:p>
+            <a:pPr>
+              <a:spcBef>
+                <a:spcPts val="1200"/>
+              </a:spcBef>
+              <a:defRPr sz="1800"/>
+            </a:pPr>
+          </a:p>
+          <a:p>
+            <a:pPr>
+              <a:spcBef>
+                <a:spcPts val="1200"/>
+              </a:spcBef>
+              <a:defRPr sz="1800"/>
+            </a:pPr>
+            <a:r>
+              <a:t>• 数字孪生城市</a:t>
+            </a:r>
+          </a:p>
+          <a:p>
+            <a:pPr>
+              <a:spcBef>
+                <a:spcPts val="1200"/>
+              </a:spcBef>
+              <a:defRPr sz="1800"/>
+            </a:pPr>
+            <a:r>
+              <a:t>  - 虚拟城市模型实时同步物理世界</a:t>
+            </a:r>
+          </a:p>
+          <a:p>
+            <a:pPr>
+              <a:spcBef>
+                <a:spcPts val="1200"/>
+              </a:spcBef>
+              <a:defRPr sz="1800"/>
+            </a:pPr>
+            <a:r>
+              <a:t>  - 在建设前测试城市决策</a:t>
+            </a:r>
+          </a:p>
+          <a:p>
+            <a:pPr>
+              <a:spcBef>
+                <a:spcPts val="1200"/>
+              </a:spcBef>
+              <a:defRPr sz="1800"/>
+            </a:pPr>
+            <a:r>
+              <a:t>  - 预测性维护与资源优化</a:t>
             </a:r>
           </a:p>
         </p:txBody>
@@ -5480,59 +4601,14 @@
       <p:grpSpPr/>
       <p:sp>
         <p:nvSpPr>
-          <p:cNvPr id="2" name="Rectangle 1"/>
-          <p:cNvSpPr/>
+          <p:cNvPr id="2" name="TextBox 1"/>
+          <p:cNvSpPr txBox="1"/>
           <p:nvPr/>
         </p:nvSpPr>
         <p:spPr>
           <a:xfrm>
-            <a:off x="0" y="0"/>
-            <a:ext cx="9144000" cy="914400"/>
-          </a:xfrm>
-          <a:prstGeom prst="rect">
-            <a:avLst/>
-          </a:prstGeom>
-          <a:solidFill>
-            <a:srgbClr val="0F4C81"/>
-          </a:solidFill>
-          <a:ln>
-            <a:solidFill>
-              <a:srgbClr val="0F4C81"/>
-            </a:solidFill>
-          </a:ln>
-        </p:spPr>
-        <p:style>
-          <a:lnRef idx="1">
-            <a:schemeClr val="accent1"/>
-          </a:lnRef>
-          <a:fillRef idx="3">
-            <a:schemeClr val="accent1"/>
-          </a:fillRef>
-          <a:effectRef idx="2">
-            <a:schemeClr val="accent1"/>
-          </a:effectRef>
-          <a:fontRef idx="minor">
-            <a:schemeClr val="lt1"/>
-          </a:fontRef>
-        </p:style>
-        <p:txBody>
-          <a:bodyPr rtlCol="0" anchor="ctr"/>
-          <a:lstStyle/>
-          <a:p>
-            <a:pPr algn="ctr"/>
-          </a:p>
-        </p:txBody>
-      </p:sp>
-      <p:sp>
-        <p:nvSpPr>
-          <p:cNvPr id="3" name="TextBox 2"/>
-          <p:cNvSpPr txBox="1"/>
-          <p:nvPr/>
-        </p:nvSpPr>
-        <p:spPr>
-          <a:xfrm>
-            <a:off x="457200" y="182880"/>
-            <a:ext cx="8229600" cy="548640"/>
+            <a:off x="457200" y="457200"/>
+            <a:ext cx="8229600" cy="731520"/>
           </a:xfrm>
           <a:prstGeom prst="rect">
             <a:avLst/>
@@ -5548,26 +4624,26 @@
             <a:pPr>
               <a:defRPr sz="3200" b="1">
                 <a:solidFill>
-                  <a:srgbClr val="FFFFFF"/>
+                  <a:srgbClr val="003366"/>
                 </a:solidFill>
               </a:defRPr>
             </a:pPr>
             <a:r>
-              <a:t>04 成功案例分析（1/2）</a:t>
-            </a:r>
-          </a:p>
-        </p:txBody>
-      </p:sp>
-      <p:sp>
-        <p:nvSpPr>
-          <p:cNvPr id="4" name="TextBox 3"/>
+              <a:t>4. 成功案例分析（上）</a:t>
+            </a:r>
+          </a:p>
+        </p:txBody>
+      </p:sp>
+      <p:sp>
+        <p:nvSpPr>
+          <p:cNvPr id="3" name="TextBox 2"/>
           <p:cNvSpPr txBox="1"/>
           <p:nvPr/>
         </p:nvSpPr>
         <p:spPr>
           <a:xfrm>
             <a:off x="731520" y="1371600"/>
-            <a:ext cx="7680960" cy="5029200"/>
+            <a:ext cx="7772400" cy="5029200"/>
           </a:xfrm>
           <a:prstGeom prst="rect">
             <a:avLst/>
@@ -5584,203 +4660,95 @@
               <a:spcBef>
                 <a:spcPts val="1200"/>
               </a:spcBef>
-              <a:defRPr sz="1800">
-                <a:solidFill>
-                  <a:srgbClr val="323232"/>
-                </a:solidFill>
-              </a:defRPr>
-            </a:pPr>
-            <a:r>
-              <a:t>新加坡 - iTransport系统</a:t>
-            </a:r>
-          </a:p>
-          <a:p>
-            <a:pPr>
-              <a:spcBef>
-                <a:spcPts val="1200"/>
-              </a:spcBef>
-              <a:defRPr sz="1800">
-                <a:solidFill>
-                  <a:srgbClr val="323232"/>
-                </a:solidFill>
-              </a:defRPr>
-            </a:pPr>
-            <a:r>
-              <a:t>   全球领先的智能交通管理系统</a:t>
-            </a:r>
-          </a:p>
-          <a:p>
-            <a:pPr>
-              <a:spcBef>
-                <a:spcPts val="1200"/>
-              </a:spcBef>
-              <a:defRPr sz="1800">
-                <a:solidFill>
-                  <a:srgbClr val="323232"/>
-                </a:solidFill>
-              </a:defRPr>
-            </a:pPr>
-            <a:r>
-              <a:t>   整合公共交通、私人交通和共享出行</a:t>
-            </a:r>
-          </a:p>
-          <a:p>
-            <a:pPr>
-              <a:spcBef>
-                <a:spcPts val="1200"/>
-              </a:spcBef>
-              <a:defRPr sz="1800">
-                <a:solidFill>
-                  <a:srgbClr val="323232"/>
-                </a:solidFill>
-              </a:defRPr>
-            </a:pPr>
-            <a:r>
-              <a:t>   实时优化交通流量，减少拥堵30%以上</a:t>
-            </a:r>
-          </a:p>
-          <a:p>
-            <a:pPr>
-              <a:spcBef>
-                <a:spcPts val="1200"/>
-              </a:spcBef>
-              <a:defRPr sz="1800">
-                <a:solidFill>
-                  <a:srgbClr val="323232"/>
-                </a:solidFill>
-              </a:defRPr>
-            </a:pPr>
-          </a:p>
-          <a:p>
-            <a:pPr>
-              <a:spcBef>
-                <a:spcPts val="1200"/>
-              </a:spcBef>
-              <a:defRPr sz="1800">
-                <a:solidFill>
-                  <a:srgbClr val="323232"/>
-                </a:solidFill>
-              </a:defRPr>
-            </a:pPr>
-            <a:r>
-              <a:t>卡塔尔Lusail City - AGIL智慧城市操作系统</a:t>
-            </a:r>
-          </a:p>
-          <a:p>
-            <a:pPr>
-              <a:spcBef>
-                <a:spcPts val="1200"/>
-              </a:spcBef>
-              <a:defRPr sz="1800">
-                <a:solidFill>
-                  <a:srgbClr val="323232"/>
-                </a:solidFill>
-              </a:defRPr>
-            </a:pPr>
-            <a:r>
-              <a:t>   全球首个完全智能化的新建城市</a:t>
-            </a:r>
-          </a:p>
-          <a:p>
-            <a:pPr>
-              <a:spcBef>
-                <a:spcPts val="1200"/>
-              </a:spcBef>
-              <a:defRPr sz="1800">
-                <a:solidFill>
-                  <a:srgbClr val="323232"/>
-                </a:solidFill>
-              </a:defRPr>
-            </a:pPr>
-            <a:r>
-              <a:t>   统一平台管理能源、交通、安防、公共设施</a:t>
-            </a:r>
-          </a:p>
-          <a:p>
-            <a:pPr>
-              <a:spcBef>
-                <a:spcPts val="1200"/>
-              </a:spcBef>
-              <a:defRPr sz="1800">
-                <a:solidFill>
-                  <a:srgbClr val="323232"/>
-                </a:solidFill>
-              </a:defRPr>
-            </a:pPr>
-            <a:r>
-              <a:t>   AI驱动的城市大脑实现自主运营</a:t>
-            </a:r>
-          </a:p>
-          <a:p>
-            <a:pPr>
-              <a:spcBef>
-                <a:spcPts val="1200"/>
-              </a:spcBef>
-              <a:defRPr sz="1800">
-                <a:solidFill>
-                  <a:srgbClr val="323232"/>
-                </a:solidFill>
-              </a:defRPr>
-            </a:pPr>
-          </a:p>
-          <a:p>
-            <a:pPr>
-              <a:spcBef>
-                <a:spcPts val="1200"/>
-              </a:spcBef>
-              <a:defRPr sz="1800">
-                <a:solidFill>
-                  <a:srgbClr val="323232"/>
-                </a:solidFill>
-              </a:defRPr>
-            </a:pPr>
-            <a:r>
-              <a:t>北京 - AI之城</a:t>
-            </a:r>
-          </a:p>
-          <a:p>
-            <a:pPr>
-              <a:spcBef>
-                <a:spcPts val="1200"/>
-              </a:spcBef>
-              <a:defRPr sz="1800">
-                <a:solidFill>
-                  <a:srgbClr val="323232"/>
-                </a:solidFill>
-              </a:defRPr>
-            </a:pPr>
-            <a:r>
-              <a:t>   2025年AI核心产业规模达3500亿元，占全国50%</a:t>
-            </a:r>
-          </a:p>
-          <a:p>
-            <a:pPr>
-              <a:spcBef>
-                <a:spcPts val="1200"/>
-              </a:spcBef>
-              <a:defRPr sz="1800">
-                <a:solidFill>
-                  <a:srgbClr val="323232"/>
-                </a:solidFill>
-              </a:defRPr>
-            </a:pPr>
-            <a:r>
-              <a:t>   AI相关企业2400家，占全国总量50%</a:t>
-            </a:r>
-          </a:p>
-          <a:p>
-            <a:pPr>
-              <a:spcBef>
-                <a:spcPts val="1200"/>
-              </a:spcBef>
-              <a:defRPr sz="1800">
-                <a:solidFill>
-                  <a:srgbClr val="323232"/>
-                </a:solidFill>
-              </a:defRPr>
-            </a:pPr>
-            <a:r>
-              <a:t>   每15元GDP中有1元直接来自AI产业</a:t>
+              <a:defRPr sz="1800"/>
+            </a:pPr>
+            <a:r>
+              <a:t>• 案例1：中国城市AI智能体部署</a:t>
+            </a:r>
+          </a:p>
+          <a:p>
+            <a:pPr>
+              <a:spcBef>
+                <a:spcPts val="1200"/>
+              </a:spcBef>
+              <a:defRPr sz="1800"/>
+            </a:pPr>
+            <a:r>
+              <a:t>  - 覆盖范围：预计2027年70%的中国城市</a:t>
+            </a:r>
+          </a:p>
+          <a:p>
+            <a:pPr>
+              <a:spcBef>
+                <a:spcPts val="1200"/>
+              </a:spcBef>
+              <a:defRPr sz="1800"/>
+            </a:pPr>
+            <a:r>
+              <a:t>  - 应用场景：交通调度、能源管理、应急响应</a:t>
+            </a:r>
+          </a:p>
+          <a:p>
+            <a:pPr>
+              <a:spcBef>
+                <a:spcPts val="1200"/>
+              </a:spcBef>
+              <a:defRPr sz="1800"/>
+            </a:pPr>
+            <a:r>
+              <a:t>  - 成效：工作流程自动化，效率提升30%+</a:t>
+            </a:r>
+          </a:p>
+          <a:p>
+            <a:pPr>
+              <a:spcBef>
+                <a:spcPts val="1200"/>
+              </a:spcBef>
+              <a:defRPr sz="1800"/>
+            </a:pPr>
+          </a:p>
+          <a:p>
+            <a:pPr>
+              <a:spcBef>
+                <a:spcPts val="1200"/>
+              </a:spcBef>
+              <a:defRPr sz="1800"/>
+            </a:pPr>
+            <a:r>
+              <a:t>• 案例2：广州天河区智慧政务</a:t>
+            </a:r>
+          </a:p>
+          <a:p>
+            <a:pPr>
+              <a:spcBef>
+                <a:spcPts val="1200"/>
+              </a:spcBef>
+              <a:defRPr sz="1800"/>
+            </a:pPr>
+            <a:r>
+              <a:t>  - 京华信息智慧政务入选AI场景应用案例集</a:t>
+            </a:r>
+          </a:p>
+          <a:p>
+            <a:pPr>
+              <a:spcBef>
+                <a:spcPts val="1200"/>
+              </a:spcBef>
+              <a:defRPr sz="1800"/>
+            </a:pPr>
+            <a:r>
+              <a:t>  - AI技术应用于公文处理、审核、项目管理</a:t>
+            </a:r>
+          </a:p>
+          <a:p>
+            <a:pPr>
+              <a:spcBef>
+                <a:spcPts val="1200"/>
+              </a:spcBef>
+              <a:defRPr sz="1800"/>
+            </a:pPr>
+            <a:r>
+              <a:t>  - 交通热线服务智能化升级</a:t>
             </a:r>
           </a:p>
         </p:txBody>
@@ -5805,59 +4773,14 @@
       <p:grpSpPr/>
       <p:sp>
         <p:nvSpPr>
-          <p:cNvPr id="2" name="Rectangle 1"/>
-          <p:cNvSpPr/>
+          <p:cNvPr id="2" name="TextBox 1"/>
+          <p:cNvSpPr txBox="1"/>
           <p:nvPr/>
         </p:nvSpPr>
         <p:spPr>
           <a:xfrm>
-            <a:off x="0" y="0"/>
-            <a:ext cx="9144000" cy="914400"/>
-          </a:xfrm>
-          <a:prstGeom prst="rect">
-            <a:avLst/>
-          </a:prstGeom>
-          <a:solidFill>
-            <a:srgbClr val="0F4C81"/>
-          </a:solidFill>
-          <a:ln>
-            <a:solidFill>
-              <a:srgbClr val="0F4C81"/>
-            </a:solidFill>
-          </a:ln>
-        </p:spPr>
-        <p:style>
-          <a:lnRef idx="1">
-            <a:schemeClr val="accent1"/>
-          </a:lnRef>
-          <a:fillRef idx="3">
-            <a:schemeClr val="accent1"/>
-          </a:fillRef>
-          <a:effectRef idx="2">
-            <a:schemeClr val="accent1"/>
-          </a:effectRef>
-          <a:fontRef idx="minor">
-            <a:schemeClr val="lt1"/>
-          </a:fontRef>
-        </p:style>
-        <p:txBody>
-          <a:bodyPr rtlCol="0" anchor="ctr"/>
-          <a:lstStyle/>
-          <a:p>
-            <a:pPr algn="ctr"/>
-          </a:p>
-        </p:txBody>
-      </p:sp>
-      <p:sp>
-        <p:nvSpPr>
-          <p:cNvPr id="3" name="TextBox 2"/>
-          <p:cNvSpPr txBox="1"/>
-          <p:nvPr/>
-        </p:nvSpPr>
-        <p:spPr>
-          <a:xfrm>
-            <a:off x="457200" y="182880"/>
-            <a:ext cx="8229600" cy="548640"/>
+            <a:off x="457200" y="457200"/>
+            <a:ext cx="8229600" cy="731520"/>
           </a:xfrm>
           <a:prstGeom prst="rect">
             <a:avLst/>
@@ -5873,26 +4796,26 @@
             <a:pPr>
               <a:defRPr sz="3200" b="1">
                 <a:solidFill>
-                  <a:srgbClr val="FFFFFF"/>
+                  <a:srgbClr val="003366"/>
                 </a:solidFill>
               </a:defRPr>
             </a:pPr>
             <a:r>
-              <a:t>04 成功案例分析（2/2）</a:t>
-            </a:r>
-          </a:p>
-        </p:txBody>
-      </p:sp>
-      <p:sp>
-        <p:nvSpPr>
-          <p:cNvPr id="4" name="TextBox 3"/>
+              <a:t>4. 成功案例分析（下）</a:t>
+            </a:r>
+          </a:p>
+        </p:txBody>
+      </p:sp>
+      <p:sp>
+        <p:nvSpPr>
+          <p:cNvPr id="3" name="TextBox 2"/>
           <p:cNvSpPr txBox="1"/>
           <p:nvPr/>
         </p:nvSpPr>
         <p:spPr>
           <a:xfrm>
             <a:off x="731520" y="1371600"/>
-            <a:ext cx="7680960" cy="5029200"/>
+            <a:ext cx="7772400" cy="5029200"/>
           </a:xfrm>
           <a:prstGeom prst="rect">
             <a:avLst/>
@@ -5909,203 +4832,95 @@
               <a:spcBef>
                 <a:spcPts val="1200"/>
               </a:spcBef>
-              <a:defRPr sz="1800">
-                <a:solidFill>
-                  <a:srgbClr val="323232"/>
-                </a:solidFill>
-              </a:defRPr>
-            </a:pPr>
-            <a:r>
-              <a:t>迪拜 - 智慧城市2.0</a:t>
-            </a:r>
-          </a:p>
-          <a:p>
-            <a:pPr>
-              <a:spcBef>
-                <a:spcPts val="1200"/>
-              </a:spcBef>
-              <a:defRPr sz="1800">
-                <a:solidFill>
-                  <a:srgbClr val="323232"/>
-                </a:solidFill>
-              </a:defRPr>
-            </a:pPr>
-            <a:r>
-              <a:t>   2025年智慧城市指数亚洲地区领先</a:t>
-            </a:r>
-          </a:p>
-          <a:p>
-            <a:pPr>
-              <a:spcBef>
-                <a:spcPts val="1200"/>
-              </a:spcBef>
-              <a:defRPr sz="1800">
-                <a:solidFill>
-                  <a:srgbClr val="323232"/>
-                </a:solidFill>
-              </a:defRPr>
-            </a:pPr>
-            <a:r>
-              <a:t>   全面推进数字政府和智能服务</a:t>
-            </a:r>
-          </a:p>
-          <a:p>
-            <a:pPr>
-              <a:spcBef>
-                <a:spcPts val="1200"/>
-              </a:spcBef>
-              <a:defRPr sz="1800">
-                <a:solidFill>
-                  <a:srgbClr val="323232"/>
-                </a:solidFill>
-              </a:defRPr>
-            </a:pPr>
-            <a:r>
-              <a:t>   目标2030年成为全球最智慧城市</a:t>
-            </a:r>
-          </a:p>
-          <a:p>
-            <a:pPr>
-              <a:spcBef>
-                <a:spcPts val="1200"/>
-              </a:spcBef>
-              <a:defRPr sz="1800">
-                <a:solidFill>
-                  <a:srgbClr val="323232"/>
-                </a:solidFill>
-              </a:defRPr>
-            </a:pPr>
-          </a:p>
-          <a:p>
-            <a:pPr>
-              <a:spcBef>
-                <a:spcPts val="1200"/>
-              </a:spcBef>
-              <a:defRPr sz="1800">
-                <a:solidFill>
-                  <a:srgbClr val="323232"/>
-                </a:solidFill>
-              </a:defRPr>
-            </a:pPr>
-            <a:r>
-              <a:t>香港 - 锐眼计划</a:t>
-            </a:r>
-          </a:p>
-          <a:p>
-            <a:pPr>
-              <a:spcBef>
-                <a:spcPts val="1200"/>
-              </a:spcBef>
-              <a:defRPr sz="1800">
-                <a:solidFill>
-                  <a:srgbClr val="323232"/>
-                </a:solidFill>
-              </a:defRPr>
-            </a:pPr>
-            <a:r>
-              <a:t>   每年增加超过2万支智能摄像头</a:t>
-            </a:r>
-          </a:p>
-          <a:p>
-            <a:pPr>
-              <a:spcBef>
-                <a:spcPts val="1200"/>
-              </a:spcBef>
-              <a:defRPr sz="1800">
-                <a:solidFill>
-                  <a:srgbClr val="323232"/>
-                </a:solidFill>
-              </a:defRPr>
-            </a:pPr>
-            <a:r>
-              <a:t>   2028年达到约60,000支的覆盖规模</a:t>
-            </a:r>
-          </a:p>
-          <a:p>
-            <a:pPr>
-              <a:spcBef>
-                <a:spcPts val="1200"/>
-              </a:spcBef>
-              <a:defRPr sz="1800">
-                <a:solidFill>
-                  <a:srgbClr val="323232"/>
-                </a:solidFill>
-              </a:defRPr>
-            </a:pPr>
-            <a:r>
-              <a:t>   AI视频分析提升公共安全和城市管理效率</a:t>
-            </a:r>
-          </a:p>
-          <a:p>
-            <a:pPr>
-              <a:spcBef>
-                <a:spcPts val="1200"/>
-              </a:spcBef>
-              <a:defRPr sz="1800">
-                <a:solidFill>
-                  <a:srgbClr val="323232"/>
-                </a:solidFill>
-              </a:defRPr>
-            </a:pPr>
-          </a:p>
-          <a:p>
-            <a:pPr>
-              <a:spcBef>
-                <a:spcPts val="1200"/>
-              </a:spcBef>
-              <a:defRPr sz="1800">
-                <a:solidFill>
-                  <a:srgbClr val="323232"/>
-                </a:solidFill>
-              </a:defRPr>
-            </a:pPr>
-            <a:r>
-              <a:t>济南 - AI泉城赋能行动</a:t>
-            </a:r>
-          </a:p>
-          <a:p>
-            <a:pPr>
-              <a:spcBef>
-                <a:spcPts val="1200"/>
-              </a:spcBef>
-              <a:defRPr sz="1800">
-                <a:solidFill>
-                  <a:srgbClr val="323232"/>
-                </a:solidFill>
-              </a:defRPr>
-            </a:pPr>
-            <a:r>
-              <a:t>   重点围绕数字政府、制造、医疗、能源、交通等领域</a:t>
-            </a:r>
-          </a:p>
-          <a:p>
-            <a:pPr>
-              <a:spcBef>
-                <a:spcPts val="1200"/>
-              </a:spcBef>
-              <a:defRPr sz="1800">
-                <a:solidFill>
-                  <a:srgbClr val="323232"/>
-                </a:solidFill>
-              </a:defRPr>
-            </a:pPr>
-            <a:r>
-              <a:t>   构建人工智能应用场景体系</a:t>
-            </a:r>
-          </a:p>
-          <a:p>
-            <a:pPr>
-              <a:spcBef>
-                <a:spcPts val="1200"/>
-              </a:spcBef>
-              <a:defRPr sz="1800">
-                <a:solidFill>
-                  <a:srgbClr val="323232"/>
-                </a:solidFill>
-              </a:defRPr>
-            </a:pPr>
-            <a:r>
-              <a:t>   到2026年核心产业规模显著增长</a:t>
+              <a:defRPr sz="1800"/>
+            </a:pPr>
+            <a:r>
+              <a:t>• 案例3：高雄智慧城市展（2026年3月）</a:t>
+            </a:r>
+          </a:p>
+          <a:p>
+            <a:pPr>
+              <a:spcBef>
+                <a:spcPts val="1200"/>
+              </a:spcBef>
+              <a:defRPr sz="1800"/>
+            </a:pPr>
+            <a:r>
+              <a:t>  - 展示5年智慧城市建设成果</a:t>
+            </a:r>
+          </a:p>
+          <a:p>
+            <a:pPr>
+              <a:spcBef>
+                <a:spcPts val="1200"/>
+              </a:spcBef>
+              <a:defRPr sz="1800"/>
+            </a:pPr>
+            <a:r>
+              <a:t>  - AI应用覆盖城市生活各面向</a:t>
+            </a:r>
+          </a:p>
+          <a:p>
+            <a:pPr>
+              <a:spcBef>
+                <a:spcPts val="1200"/>
+              </a:spcBef>
+              <a:defRPr sz="1800"/>
+            </a:pPr>
+            <a:r>
+              <a:t>  - 深入生活场景的AI成果展示</a:t>
+            </a:r>
+          </a:p>
+          <a:p>
+            <a:pPr>
+              <a:spcBef>
+                <a:spcPts val="1200"/>
+              </a:spcBef>
+              <a:defRPr sz="1800"/>
+            </a:pPr>
+          </a:p>
+          <a:p>
+            <a:pPr>
+              <a:spcBef>
+                <a:spcPts val="1200"/>
+              </a:spcBef>
+              <a:defRPr sz="1800"/>
+            </a:pPr>
+            <a:r>
+              <a:t>• 案例4：Sunnyvale（硅谷核心城市）</a:t>
+            </a:r>
+          </a:p>
+          <a:p>
+            <a:pPr>
+              <a:spcBef>
+                <a:spcPts val="1200"/>
+              </a:spcBef>
+              <a:defRPr sz="1800"/>
+            </a:pPr>
+            <a:r>
+              <a:t>  - 市长Larry Klein：AI正在影响所有城市</a:t>
+            </a:r>
+          </a:p>
+          <a:p>
+            <a:pPr>
+              <a:spcBef>
+                <a:spcPts val="1200"/>
+              </a:spcBef>
+              <a:defRPr sz="1800"/>
+            </a:pPr>
+            <a:r>
+              <a:t>  - 智能许可审批与城市规划</a:t>
+            </a:r>
+          </a:p>
+          <a:p>
+            <a:pPr>
+              <a:spcBef>
+                <a:spcPts val="1200"/>
+              </a:spcBef>
+              <a:defRPr sz="1800"/>
+            </a:pPr>
+            <a:r>
+              <a:t>  - 公民服务与资产管理智能化</a:t>
             </a:r>
           </a:p>
         </p:txBody>

</xml_diff>

<commit_message>
Harden task output recovery and output path parsing
</commit_message>
<xml_diff>
--- a/sidecar/2026年AI在智慧城市中的发展.pptx
+++ b/sidecar/2026年AI在智慧城市中的发展.pptx
@@ -13,10 +13,6 @@
     <p:sldId id="261" r:id="rId12"/>
     <p:sldId id="262" r:id="rId13"/>
     <p:sldId id="263" r:id="rId14"/>
-    <p:sldId id="264" r:id="rId15"/>
-    <p:sldId id="265" r:id="rId16"/>
-    <p:sldId id="266" r:id="rId17"/>
-    <p:sldId id="267" r:id="rId18"/>
   </p:sldIdLst>
   <p:sldSz cx="9144000" cy="6858000" type="screen4x3"/>
   <p:notesSz cx="6858000" cy="9144000"/>
@@ -3101,33 +3097,19 @@
       <p:grpSpPr/>
       <p:sp>
         <p:nvSpPr>
-          <p:cNvPr id="2" name="TextBox 1"/>
-          <p:cNvSpPr txBox="1"/>
-          <p:nvPr/>
-        </p:nvSpPr>
-        <p:spPr>
-          <a:xfrm>
-            <a:off x="914400" y="2286000"/>
-            <a:ext cx="7315200" cy="914400"/>
-          </a:xfrm>
-          <a:prstGeom prst="rect">
-            <a:avLst/>
-          </a:prstGeom>
-          <a:noFill/>
-        </p:spPr>
-        <p:txBody>
-          <a:bodyPr wrap="none">
-            <a:spAutoFit/>
-          </a:bodyPr>
-          <a:lstStyle/>
-          <a:p>
-            <a:pPr algn="ctr">
-              <a:defRPr sz="4400" b="1">
-                <a:solidFill>
-                  <a:srgbClr val="003366"/>
-                </a:solidFill>
-              </a:defRPr>
-            </a:pPr>
+          <p:cNvPr id="2" name="Title 1"/>
+          <p:cNvSpPr>
+            <a:spLocks noGrp="1"/>
+          </p:cNvSpPr>
+          <p:nvPr>
+            <p:ph type="ctrTitle"/>
+          </p:nvPr>
+        </p:nvSpPr>
+        <p:spPr/>
+        <p:txBody>
+          <a:bodyPr/>
+          <a:lstStyle/>
+          <a:p>
             <a:r>
               <a:t>2026年AI在智慧城市中的发展</a:t>
             </a:r>
@@ -3136,478 +3118,26 @@
       </p:sp>
       <p:sp>
         <p:nvSpPr>
-          <p:cNvPr id="3" name="TextBox 2"/>
-          <p:cNvSpPr txBox="1"/>
-          <p:nvPr/>
-        </p:nvSpPr>
-        <p:spPr>
-          <a:xfrm>
-            <a:off x="914400" y="3474720"/>
-            <a:ext cx="7315200" cy="731520"/>
-          </a:xfrm>
-          <a:prstGeom prst="rect">
-            <a:avLst/>
-          </a:prstGeom>
-          <a:noFill/>
-        </p:spPr>
-        <p:txBody>
-          <a:bodyPr wrap="none">
-            <a:spAutoFit/>
-          </a:bodyPr>
-          <a:lstStyle/>
-          <a:p>
-            <a:pPr algn="ctr">
-              <a:defRPr sz="2400">
-                <a:solidFill>
-                  <a:srgbClr val="646464"/>
-                </a:solidFill>
-              </a:defRPr>
-            </a:pPr>
-            <a:r>
-              <a:t>人工智能驱动的城市未来</a:t>
-            </a:r>
-          </a:p>
-        </p:txBody>
-      </p:sp>
-    </p:spTree>
-  </p:cSld>
-  <p:clrMapOvr>
-    <a:masterClrMapping/>
-  </p:clrMapOvr>
-</p:sld>
-</file>
-
-<file path=ppt/slides/slide10.xml><?xml version="1.0" encoding="utf-8"?>
-<p:sld xmlns:a="http://schemas.openxmlformats.org/drawingml/2006/main" xmlns:p="http://schemas.openxmlformats.org/presentationml/2006/main" xmlns:r="http://schemas.openxmlformats.org/officeDocument/2006/relationships">
-  <p:cSld>
-    <p:spTree>
-      <p:nvGrpSpPr>
-        <p:cNvPr id="1" name=""/>
-        <p:cNvGrpSpPr/>
-        <p:nvPr/>
-      </p:nvGrpSpPr>
-      <p:grpSpPr/>
-      <p:sp>
-        <p:nvSpPr>
-          <p:cNvPr id="2" name="TextBox 1"/>
-          <p:cNvSpPr txBox="1"/>
-          <p:nvPr/>
-        </p:nvSpPr>
-        <p:spPr>
-          <a:xfrm>
-            <a:off x="457200" y="457200"/>
-            <a:ext cx="8229600" cy="731520"/>
-          </a:xfrm>
-          <a:prstGeom prst="rect">
-            <a:avLst/>
-          </a:prstGeom>
-          <a:noFill/>
-        </p:spPr>
-        <p:txBody>
-          <a:bodyPr wrap="none">
-            <a:spAutoFit/>
-          </a:bodyPr>
-          <a:lstStyle/>
-          <a:p>
-            <a:pPr>
-              <a:defRPr sz="3200" b="1">
-                <a:solidFill>
-                  <a:srgbClr val="003366"/>
-                </a:solidFill>
-              </a:defRPr>
-            </a:pPr>
-            <a:r>
-              <a:t>5. 未来展望（上）</a:t>
-            </a:r>
-          </a:p>
-        </p:txBody>
-      </p:sp>
-      <p:sp>
-        <p:nvSpPr>
-          <p:cNvPr id="3" name="TextBox 2"/>
-          <p:cNvSpPr txBox="1"/>
-          <p:nvPr/>
-        </p:nvSpPr>
-        <p:spPr>
-          <a:xfrm>
-            <a:off x="731520" y="1371600"/>
-            <a:ext cx="7772400" cy="5029200"/>
-          </a:xfrm>
-          <a:prstGeom prst="rect">
-            <a:avLst/>
-          </a:prstGeom>
-          <a:noFill/>
-        </p:spPr>
-        <p:txBody>
-          <a:bodyPr wrap="square">
-            <a:spAutoFit/>
-          </a:bodyPr>
-          <a:lstStyle/>
-          <a:p>
-            <a:pPr>
-              <a:spcBef>
-                <a:spcPts val="1200"/>
-              </a:spcBef>
-              <a:defRPr sz="1800"/>
-            </a:pPr>
-            <a:r>
-              <a:t>• 技术演进方向</a:t>
-            </a:r>
-          </a:p>
-          <a:p>
-            <a:pPr>
-              <a:spcBef>
-                <a:spcPts val="1200"/>
-              </a:spcBef>
-              <a:defRPr sz="1800"/>
-            </a:pPr>
-            <a:r>
-              <a:t>  - AI从辅助工具向自主智能体演进</a:t>
-            </a:r>
-          </a:p>
-          <a:p>
-            <a:pPr>
-              <a:spcBef>
-                <a:spcPts val="1200"/>
-              </a:spcBef>
-              <a:defRPr sz="1800"/>
-            </a:pPr>
-            <a:r>
-              <a:t>  - 多模态AI融合（视觉、语音、文本）</a:t>
-            </a:r>
-          </a:p>
-          <a:p>
-            <a:pPr>
-              <a:spcBef>
-                <a:spcPts val="1200"/>
-              </a:spcBef>
-              <a:defRPr sz="1800"/>
-            </a:pPr>
-            <a:r>
-              <a:t>  - 具身智能在城市场景的广泛应用</a:t>
-            </a:r>
-          </a:p>
-          <a:p>
-            <a:pPr>
-              <a:spcBef>
-                <a:spcPts val="1200"/>
-              </a:spcBef>
-              <a:defRPr sz="1800"/>
-            </a:pPr>
-          </a:p>
-          <a:p>
-            <a:pPr>
-              <a:spcBef>
-                <a:spcPts val="1200"/>
-              </a:spcBef>
-              <a:defRPr sz="1800"/>
-            </a:pPr>
-            <a:r>
-              <a:t>• 应用深化趋势</a:t>
-            </a:r>
-          </a:p>
-          <a:p>
-            <a:pPr>
-              <a:spcBef>
-                <a:spcPts val="1200"/>
-              </a:spcBef>
-              <a:defRPr sz="1800"/>
-            </a:pPr>
-            <a:r>
-              <a:t>  - 从单点应用向全域智能转变</a:t>
-            </a:r>
-          </a:p>
-          <a:p>
-            <a:pPr>
-              <a:spcBef>
-                <a:spcPts val="1200"/>
-              </a:spcBef>
-              <a:defRPr sz="1800"/>
-            </a:pPr>
-            <a:r>
-              <a:t>  - 跨部门数据打通与协同治理</a:t>
-            </a:r>
-          </a:p>
-          <a:p>
-            <a:pPr>
-              <a:spcBef>
-                <a:spcPts val="1200"/>
-              </a:spcBef>
-              <a:defRPr sz="1800"/>
-            </a:pPr>
-            <a:r>
-              <a:t>  - AI模型行业化、场景化定制</a:t>
-            </a:r>
-          </a:p>
-        </p:txBody>
-      </p:sp>
-    </p:spTree>
-  </p:cSld>
-  <p:clrMapOvr>
-    <a:masterClrMapping/>
-  </p:clrMapOvr>
-</p:sld>
-</file>
-
-<file path=ppt/slides/slide11.xml><?xml version="1.0" encoding="utf-8"?>
-<p:sld xmlns:a="http://schemas.openxmlformats.org/drawingml/2006/main" xmlns:p="http://schemas.openxmlformats.org/presentationml/2006/main" xmlns:r="http://schemas.openxmlformats.org/officeDocument/2006/relationships">
-  <p:cSld>
-    <p:spTree>
-      <p:nvGrpSpPr>
-        <p:cNvPr id="1" name=""/>
-        <p:cNvGrpSpPr/>
-        <p:nvPr/>
-      </p:nvGrpSpPr>
-      <p:grpSpPr/>
-      <p:sp>
-        <p:nvSpPr>
-          <p:cNvPr id="2" name="TextBox 1"/>
-          <p:cNvSpPr txBox="1"/>
-          <p:nvPr/>
-        </p:nvSpPr>
-        <p:spPr>
-          <a:xfrm>
-            <a:off x="457200" y="457200"/>
-            <a:ext cx="8229600" cy="731520"/>
-          </a:xfrm>
-          <a:prstGeom prst="rect">
-            <a:avLst/>
-          </a:prstGeom>
-          <a:noFill/>
-        </p:spPr>
-        <p:txBody>
-          <a:bodyPr wrap="none">
-            <a:spAutoFit/>
-          </a:bodyPr>
-          <a:lstStyle/>
-          <a:p>
-            <a:pPr>
-              <a:defRPr sz="3200" b="1">
-                <a:solidFill>
-                  <a:srgbClr val="003366"/>
-                </a:solidFill>
-              </a:defRPr>
-            </a:pPr>
-            <a:r>
-              <a:t>5. 未来展望（下）</a:t>
-            </a:r>
-          </a:p>
-        </p:txBody>
-      </p:sp>
-      <p:sp>
-        <p:nvSpPr>
-          <p:cNvPr id="3" name="TextBox 2"/>
-          <p:cNvSpPr txBox="1"/>
-          <p:nvPr/>
-        </p:nvSpPr>
-        <p:spPr>
-          <a:xfrm>
-            <a:off x="731520" y="1371600"/>
-            <a:ext cx="7772400" cy="5029200"/>
-          </a:xfrm>
-          <a:prstGeom prst="rect">
-            <a:avLst/>
-          </a:prstGeom>
-          <a:noFill/>
-        </p:spPr>
-        <p:txBody>
-          <a:bodyPr wrap="square">
-            <a:spAutoFit/>
-          </a:bodyPr>
-          <a:lstStyle/>
-          <a:p>
-            <a:pPr>
-              <a:spcBef>
-                <a:spcPts val="1200"/>
-              </a:spcBef>
-              <a:defRPr sz="1800"/>
-            </a:pPr>
-            <a:r>
-              <a:t>• 挑战与机遇</a:t>
-            </a:r>
-          </a:p>
-          <a:p>
-            <a:pPr>
-              <a:spcBef>
-                <a:spcPts val="1200"/>
-              </a:spcBef>
-              <a:defRPr sz="1800"/>
-            </a:pPr>
-            <a:r>
-              <a:t>  - 隐私保护与数据安全</a:t>
-            </a:r>
-          </a:p>
-          <a:p>
-            <a:pPr>
-              <a:spcBef>
-                <a:spcPts val="1200"/>
-              </a:spcBef>
-              <a:defRPr sz="1800"/>
-            </a:pPr>
-            <a:r>
-              <a:t>  - 算法公平性与伦理问题</a:t>
-            </a:r>
-          </a:p>
-          <a:p>
-            <a:pPr>
-              <a:spcBef>
-                <a:spcPts val="1200"/>
-              </a:spcBef>
-              <a:defRPr sz="1800"/>
-            </a:pPr>
-            <a:r>
-              <a:t>  - 网络安全威胁应对</a:t>
-            </a:r>
-          </a:p>
-          <a:p>
-            <a:pPr>
-              <a:spcBef>
-                <a:spcPts val="1200"/>
-              </a:spcBef>
-              <a:defRPr sz="1800"/>
-            </a:pPr>
-            <a:r>
-              <a:t>  - 数字鸿沟与包容性发展</a:t>
-            </a:r>
-          </a:p>
-          <a:p>
-            <a:pPr>
-              <a:spcBef>
-                <a:spcPts val="1200"/>
-              </a:spcBef>
-              <a:defRPr sz="1800"/>
-            </a:pPr>
-          </a:p>
-          <a:p>
-            <a:pPr>
-              <a:spcBef>
-                <a:spcPts val="1200"/>
-              </a:spcBef>
-              <a:defRPr sz="1800"/>
-            </a:pPr>
-            <a:r>
-              <a:t>• 发展目标</a:t>
-            </a:r>
-          </a:p>
-          <a:p>
-            <a:pPr>
-              <a:spcBef>
-                <a:spcPts val="1200"/>
-              </a:spcBef>
-              <a:defRPr sz="1800"/>
-            </a:pPr>
-            <a:r>
-              <a:t>  - 2027年：65%全球城市部署AI智能体</a:t>
-            </a:r>
-          </a:p>
-          <a:p>
-            <a:pPr>
-              <a:spcBef>
-                <a:spcPts val="1200"/>
-              </a:spcBef>
-              <a:defRPr sz="1800"/>
-            </a:pPr>
-            <a:r>
-              <a:t>  - 中国AI核心产业规模持续增长</a:t>
-            </a:r>
-          </a:p>
-          <a:p>
-            <a:pPr>
-              <a:spcBef>
-                <a:spcPts val="1200"/>
-              </a:spcBef>
-              <a:defRPr sz="1800"/>
-            </a:pPr>
-            <a:r>
-              <a:t>  - 智慧城市成为数字中国建设综合载体</a:t>
-            </a:r>
-          </a:p>
-        </p:txBody>
-      </p:sp>
-    </p:spTree>
-  </p:cSld>
-  <p:clrMapOvr>
-    <a:masterClrMapping/>
-  </p:clrMapOvr>
-</p:sld>
-</file>
-
-<file path=ppt/slides/slide12.xml><?xml version="1.0" encoding="utf-8"?>
-<p:sld xmlns:a="http://schemas.openxmlformats.org/drawingml/2006/main" xmlns:p="http://schemas.openxmlformats.org/presentationml/2006/main" xmlns:r="http://schemas.openxmlformats.org/officeDocument/2006/relationships">
-  <p:cSld>
-    <p:spTree>
-      <p:nvGrpSpPr>
-        <p:cNvPr id="1" name=""/>
-        <p:cNvGrpSpPr/>
-        <p:nvPr/>
-      </p:nvGrpSpPr>
-      <p:grpSpPr/>
-      <p:sp>
-        <p:nvSpPr>
-          <p:cNvPr id="2" name="TextBox 1"/>
-          <p:cNvSpPr txBox="1"/>
-          <p:nvPr/>
-        </p:nvSpPr>
-        <p:spPr>
-          <a:xfrm>
-            <a:off x="914400" y="2286000"/>
-            <a:ext cx="7315200" cy="914400"/>
-          </a:xfrm>
-          <a:prstGeom prst="rect">
-            <a:avLst/>
-          </a:prstGeom>
-          <a:noFill/>
-        </p:spPr>
-        <p:txBody>
-          <a:bodyPr wrap="none">
-            <a:spAutoFit/>
-          </a:bodyPr>
-          <a:lstStyle/>
-          <a:p>
-            <a:pPr algn="ctr">
-              <a:defRPr sz="4400" b="1">
-                <a:solidFill>
-                  <a:srgbClr val="003366"/>
-                </a:solidFill>
-              </a:defRPr>
-            </a:pPr>
-            <a:r>
-              <a:t>谢谢观看</a:t>
-            </a:r>
-          </a:p>
-        </p:txBody>
-      </p:sp>
-      <p:sp>
-        <p:nvSpPr>
-          <p:cNvPr id="3" name="TextBox 2"/>
-          <p:cNvSpPr txBox="1"/>
-          <p:nvPr/>
-        </p:nvSpPr>
-        <p:spPr>
-          <a:xfrm>
-            <a:off x="914400" y="3474720"/>
-            <a:ext cx="7315200" cy="731520"/>
-          </a:xfrm>
-          <a:prstGeom prst="rect">
-            <a:avLst/>
-          </a:prstGeom>
-          <a:noFill/>
-        </p:spPr>
-        <p:txBody>
-          <a:bodyPr wrap="none">
-            <a:spAutoFit/>
-          </a:bodyPr>
-          <a:lstStyle/>
-          <a:p>
-            <a:pPr algn="ctr">
-              <a:defRPr sz="2400">
-                <a:solidFill>
-                  <a:srgbClr val="646464"/>
-                </a:solidFill>
-              </a:defRPr>
-            </a:pPr>
-            <a:r>
-              <a:t>AI赋能，智慧未来</a:t>
+          <p:cNvPr id="3" name="Subtitle 2"/>
+          <p:cNvSpPr>
+            <a:spLocks noGrp="1"/>
+          </p:cNvSpPr>
+          <p:nvPr>
+            <p:ph type="subTitle" idx="1"/>
+          </p:nvPr>
+        </p:nvSpPr>
+        <p:spPr/>
+        <p:txBody>
+          <a:bodyPr/>
+          <a:lstStyle/>
+          <a:p>
+            <a:r>
+              <a:t>趋势、应用、案例与未来展望</a:t>
+            </a:r>
+          </a:p>
+          <a:p>
+            <a:r>
+              <a:t>基于公开资料整理（2025-2026）</a:t>
             </a:r>
           </a:p>
         </p:txBody>
@@ -3632,113 +3162,77 @@
       <p:grpSpPr/>
       <p:sp>
         <p:nvSpPr>
-          <p:cNvPr id="2" name="TextBox 1"/>
-          <p:cNvSpPr txBox="1"/>
-          <p:nvPr/>
-        </p:nvSpPr>
-        <p:spPr>
-          <a:xfrm>
-            <a:off x="457200" y="457200"/>
-            <a:ext cx="8229600" cy="731520"/>
-          </a:xfrm>
-          <a:prstGeom prst="rect">
-            <a:avLst/>
-          </a:prstGeom>
-          <a:noFill/>
-        </p:spPr>
-        <p:txBody>
-          <a:bodyPr wrap="none">
-            <a:spAutoFit/>
-          </a:bodyPr>
+          <p:cNvPr id="2" name="Title 1"/>
+          <p:cNvSpPr>
+            <a:spLocks noGrp="1"/>
+          </p:cNvSpPr>
+          <p:nvPr>
+            <p:ph type="title"/>
+          </p:nvPr>
+        </p:nvSpPr>
+        <p:spPr/>
+        <p:txBody>
+          <a:bodyPr/>
+          <a:lstStyle/>
+          <a:p>
+            <a:r>
+              <a:t>1. 智慧城市的定义和发展背景</a:t>
+            </a:r>
+          </a:p>
+        </p:txBody>
+      </p:sp>
+      <p:sp>
+        <p:nvSpPr>
+          <p:cNvPr id="3" name="Content Placeholder 2"/>
+          <p:cNvSpPr>
+            <a:spLocks noGrp="1"/>
+          </p:cNvSpPr>
+          <p:nvPr>
+            <p:ph idx="1"/>
+          </p:nvPr>
+        </p:nvSpPr>
+        <p:spPr/>
+        <p:txBody>
+          <a:bodyPr/>
           <a:lstStyle/>
           <a:p>
             <a:pPr>
-              <a:defRPr sz="3200" b="1">
-                <a:solidFill>
-                  <a:srgbClr val="003366"/>
-                </a:solidFill>
-              </a:defRPr>
+              <a:defRPr sz="2000"/>
             </a:pPr>
             <a:r>
-              <a:t>目录</a:t>
-            </a:r>
-          </a:p>
-        </p:txBody>
-      </p:sp>
-      <p:sp>
-        <p:nvSpPr>
-          <p:cNvPr id="3" name="TextBox 2"/>
-          <p:cNvSpPr txBox="1"/>
-          <p:nvPr/>
-        </p:nvSpPr>
-        <p:spPr>
-          <a:xfrm>
-            <a:off x="731520" y="1371600"/>
-            <a:ext cx="7772400" cy="5029200"/>
-          </a:xfrm>
-          <a:prstGeom prst="rect">
-            <a:avLst/>
-          </a:prstGeom>
-          <a:noFill/>
-        </p:spPr>
-        <p:txBody>
-          <a:bodyPr wrap="square">
-            <a:spAutoFit/>
-          </a:bodyPr>
-          <a:lstStyle/>
+              <a:t>智慧城市：以数据、数字基础设施与智能系统提升城市治理、公共服务与可持续发展能力。</a:t>
+            </a:r>
+          </a:p>
           <a:p>
             <a:pPr>
-              <a:spcBef>
-                <a:spcPts val="1200"/>
-              </a:spcBef>
-              <a:defRPr sz="1800"/>
+              <a:defRPr sz="2000"/>
             </a:pPr>
             <a:r>
-              <a:t>1. 智慧城市的定义和发展背景</a:t>
+              <a:t>发展驱动：城市化加速、交通拥堵、能源与碳排压力、公共安全与民生服务精细化需求。</a:t>
             </a:r>
           </a:p>
           <a:p>
             <a:pPr>
-              <a:spcBef>
-                <a:spcPts val="1200"/>
-              </a:spcBef>
-              <a:defRPr sz="1800"/>
+              <a:defRPr sz="2000"/>
             </a:pPr>
             <a:r>
-              <a:t>2. AI在智慧城市中的主要应用场景</a:t>
+              <a:t>技术底座演进：IoT感知网络 + 云/边协同 + 城市数据平台 + AI模型。</a:t>
             </a:r>
           </a:p>
           <a:p>
             <a:pPr>
-              <a:spcBef>
-                <a:spcPts val="1200"/>
-              </a:spcBef>
-              <a:defRPr sz="1800"/>
+              <a:defRPr sz="2000"/>
             </a:pPr>
             <a:r>
-              <a:t>3. 2026年最新技术和趋势</a:t>
-            </a:r>
-          </a:p>
-          <a:p>
-            <a:pPr>
-              <a:spcBef>
-                <a:spcPts val="1200"/>
-              </a:spcBef>
-              <a:defRPr sz="1800"/>
+              <a:t>治理重心变化：从‘技术导向’转向‘以人为本、可信治理、可持续与包容’。</a:t>
+            </a:r>
+          </a:p>
+          <a:p>
+            <a:pPr lvl="1">
+              <a:defRPr sz="1600"/>
             </a:pPr>
             <a:r>
-              <a:t>4. 成功案例分析</a:t>
-            </a:r>
-          </a:p>
-          <a:p>
-            <a:pPr>
-              <a:spcBef>
-                <a:spcPts val="1200"/>
-              </a:spcBef>
-              <a:defRPr sz="1800"/>
-            </a:pPr>
-            <a:r>
-              <a:t>5. 未来展望</a:t>
+              <a:t>UN-Habitat 2025《People-Centred Smart Cities》强调责任型AI、数据治理与公平性。</a:t>
             </a:r>
           </a:p>
         </p:txBody>
@@ -3763,132 +3257,77 @@
       <p:grpSpPr/>
       <p:sp>
         <p:nvSpPr>
-          <p:cNvPr id="2" name="TextBox 1"/>
-          <p:cNvSpPr txBox="1"/>
-          <p:nvPr/>
-        </p:nvSpPr>
-        <p:spPr>
-          <a:xfrm>
-            <a:off x="457200" y="457200"/>
-            <a:ext cx="8229600" cy="731520"/>
-          </a:xfrm>
-          <a:prstGeom prst="rect">
-            <a:avLst/>
-          </a:prstGeom>
-          <a:noFill/>
-        </p:spPr>
-        <p:txBody>
-          <a:bodyPr wrap="none">
-            <a:spAutoFit/>
-          </a:bodyPr>
+          <p:cNvPr id="2" name="Title 1"/>
+          <p:cNvSpPr>
+            <a:spLocks noGrp="1"/>
+          </p:cNvSpPr>
+          <p:nvPr>
+            <p:ph type="title"/>
+          </p:nvPr>
+        </p:nvSpPr>
+        <p:spPr/>
+        <p:txBody>
+          <a:bodyPr/>
+          <a:lstStyle/>
+          <a:p>
+            <a:r>
+              <a:t>2. AI在智慧城市中的主要应用场景</a:t>
+            </a:r>
+          </a:p>
+        </p:txBody>
+      </p:sp>
+      <p:sp>
+        <p:nvSpPr>
+          <p:cNvPr id="3" name="Content Placeholder 2"/>
+          <p:cNvSpPr>
+            <a:spLocks noGrp="1"/>
+          </p:cNvSpPr>
+          <p:nvPr>
+            <p:ph idx="1"/>
+          </p:nvPr>
+        </p:nvSpPr>
+        <p:spPr/>
+        <p:txBody>
+          <a:bodyPr/>
           <a:lstStyle/>
           <a:p>
             <a:pPr>
-              <a:defRPr sz="3200" b="1">
-                <a:solidFill>
-                  <a:srgbClr val="003366"/>
-                </a:solidFill>
-              </a:defRPr>
+              <a:defRPr sz="2000"/>
             </a:pPr>
             <a:r>
-              <a:t>1. 智慧城市的定义和发展背景</a:t>
-            </a:r>
-          </a:p>
-        </p:txBody>
-      </p:sp>
-      <p:sp>
-        <p:nvSpPr>
-          <p:cNvPr id="3" name="TextBox 2"/>
-          <p:cNvSpPr txBox="1"/>
-          <p:nvPr/>
-        </p:nvSpPr>
-        <p:spPr>
-          <a:xfrm>
-            <a:off x="731520" y="1371600"/>
-            <a:ext cx="7772400" cy="5029200"/>
-          </a:xfrm>
-          <a:prstGeom prst="rect">
-            <a:avLst/>
-          </a:prstGeom>
-          <a:noFill/>
-        </p:spPr>
-        <p:txBody>
-          <a:bodyPr wrap="square">
-            <a:spAutoFit/>
-          </a:bodyPr>
-          <a:lstStyle/>
+              <a:t>智能交通：信号配时优化、拥堵预测、公交/地铁运营优化、事故快速响应。</a:t>
+            </a:r>
+          </a:p>
           <a:p>
             <a:pPr>
-              <a:spcBef>
-                <a:spcPts val="1200"/>
-              </a:spcBef>
-              <a:defRPr sz="1800"/>
+              <a:defRPr sz="2000"/>
             </a:pPr>
             <a:r>
-              <a:t>• 定义：利用信息技术、物联网、大数据、云计算、人工智能等先进技术，面向城市治理、民生服务、产业发展、生态环保等核心场景的综合解决方案</a:t>
+              <a:t>公共安全与应急：视频智能分析、风险预警、灾害监测与联动指挥。</a:t>
             </a:r>
           </a:p>
           <a:p>
             <a:pPr>
-              <a:spcBef>
-                <a:spcPts val="1200"/>
-              </a:spcBef>
-              <a:defRPr sz="1800"/>
+              <a:defRPr sz="2000"/>
             </a:pPr>
+            <a:r>
+              <a:t>城市治理与政务服务：AI客服、审批辅助、跨部门协同、城市运行“一网统管”。</a:t>
+            </a:r>
           </a:p>
           <a:p>
             <a:pPr>
-              <a:spcBef>
-                <a:spcPts val="1200"/>
-              </a:spcBef>
-              <a:defRPr sz="1800"/>
+              <a:defRPr sz="2000"/>
             </a:pPr>
             <a:r>
-              <a:t>• 发展背景：</a:t>
+              <a:t>能源与环保：建筑能耗优化、智能电网调度、空气/水环境监测。</a:t>
             </a:r>
           </a:p>
           <a:p>
             <a:pPr>
-              <a:spcBef>
-                <a:spcPts val="1200"/>
-              </a:spcBef>
-              <a:defRPr sz="1800"/>
+              <a:defRPr sz="2000"/>
             </a:pPr>
             <a:r>
-              <a:t>  - 全球城市化进程加速，城市管理面临复杂挑战</a:t>
-            </a:r>
-          </a:p>
-          <a:p>
-            <a:pPr>
-              <a:spcBef>
-                <a:spcPts val="1200"/>
-              </a:spcBef>
-              <a:defRPr sz="1800"/>
-            </a:pPr>
-            <a:r>
-              <a:t>  - AI技术成熟度提升，为智慧城市提供核心驱动力</a:t>
-            </a:r>
-          </a:p>
-          <a:p>
-            <a:pPr>
-              <a:spcBef>
-                <a:spcPts val="1200"/>
-              </a:spcBef>
-              <a:defRPr sz="1800"/>
-            </a:pPr>
-            <a:r>
-              <a:t>  - 中国智慧城市IT解决方案市场规模突破1.2万亿元</a:t>
-            </a:r>
-          </a:p>
-          <a:p>
-            <a:pPr>
-              <a:spcBef>
-                <a:spcPts val="1200"/>
-              </a:spcBef>
-              <a:defRPr sz="1800"/>
-            </a:pPr>
-            <a:r>
-              <a:t>  - 城市全域数字化转型成为国家战略重点</a:t>
+              <a:t>医疗与民生：医保问答、心理健康辅助、社区服务精准匹配。</a:t>
             </a:r>
           </a:p>
         </p:txBody>
@@ -3913,154 +3352,77 @@
       <p:grpSpPr/>
       <p:sp>
         <p:nvSpPr>
-          <p:cNvPr id="2" name="TextBox 1"/>
-          <p:cNvSpPr txBox="1"/>
-          <p:nvPr/>
-        </p:nvSpPr>
-        <p:spPr>
-          <a:xfrm>
-            <a:off x="457200" y="457200"/>
-            <a:ext cx="8229600" cy="731520"/>
-          </a:xfrm>
-          <a:prstGeom prst="rect">
-            <a:avLst/>
-          </a:prstGeom>
-          <a:noFill/>
-        </p:spPr>
-        <p:txBody>
-          <a:bodyPr wrap="none">
-            <a:spAutoFit/>
-          </a:bodyPr>
+          <p:cNvPr id="2" name="Title 1"/>
+          <p:cNvSpPr>
+            <a:spLocks noGrp="1"/>
+          </p:cNvSpPr>
+          <p:nvPr>
+            <p:ph type="title"/>
+          </p:nvPr>
+        </p:nvSpPr>
+        <p:spPr/>
+        <p:txBody>
+          <a:bodyPr/>
+          <a:lstStyle/>
+          <a:p>
+            <a:r>
+              <a:t>3. 2026年最新技术和趋势</a:t>
+            </a:r>
+          </a:p>
+        </p:txBody>
+      </p:sp>
+      <p:sp>
+        <p:nvSpPr>
+          <p:cNvPr id="3" name="Content Placeholder 2"/>
+          <p:cNvSpPr>
+            <a:spLocks noGrp="1"/>
+          </p:cNvSpPr>
+          <p:nvPr>
+            <p:ph idx="1"/>
+          </p:nvPr>
+        </p:nvSpPr>
+        <p:spPr/>
+        <p:txBody>
+          <a:bodyPr/>
           <a:lstStyle/>
           <a:p>
             <a:pPr>
-              <a:defRPr sz="3200" b="1">
-                <a:solidFill>
-                  <a:srgbClr val="003366"/>
-                </a:solidFill>
-              </a:defRPr>
+              <a:defRPr sz="2000"/>
             </a:pPr>
             <a:r>
-              <a:t>2. AI在智慧城市中的主要应用场景（上）</a:t>
-            </a:r>
-          </a:p>
-        </p:txBody>
-      </p:sp>
-      <p:sp>
-        <p:nvSpPr>
-          <p:cNvPr id="3" name="TextBox 2"/>
-          <p:cNvSpPr txBox="1"/>
-          <p:nvPr/>
-        </p:nvSpPr>
-        <p:spPr>
-          <a:xfrm>
-            <a:off x="731520" y="1371600"/>
-            <a:ext cx="7772400" cy="5029200"/>
-          </a:xfrm>
-          <a:prstGeom prst="rect">
-            <a:avLst/>
-          </a:prstGeom>
-          <a:noFill/>
-        </p:spPr>
-        <p:txBody>
-          <a:bodyPr wrap="square">
-            <a:spAutoFit/>
-          </a:bodyPr>
-          <a:lstStyle/>
+              <a:t>城市数字孪生进入‘运营级’：从可视化走向实时闭环决策与仿真推演。</a:t>
+            </a:r>
+          </a:p>
           <a:p>
             <a:pPr>
-              <a:spcBef>
-                <a:spcPts val="1200"/>
-              </a:spcBef>
-              <a:defRPr sz="1800"/>
+              <a:defRPr sz="2000"/>
             </a:pPr>
             <a:r>
-              <a:t>• 智能交通管理</a:t>
+              <a:t>边缘AI规模化：在路口、站点、园区侧实时推理，降低时延与带宽成本。</a:t>
             </a:r>
           </a:p>
           <a:p>
             <a:pPr>
-              <a:spcBef>
-                <a:spcPts val="1200"/>
-              </a:spcBef>
-              <a:defRPr sz="1800"/>
+              <a:defRPr sz="2000"/>
             </a:pPr>
             <a:r>
-              <a:t>  - AI交通系统减少拥堵25%</a:t>
+              <a:t>多模态大模型融入城市中枢：文本、图像、视频、时空数据联合决策。</a:t>
             </a:r>
           </a:p>
           <a:p>
             <a:pPr>
-              <a:spcBef>
-                <a:spcPts val="1200"/>
-              </a:spcBef>
-              <a:defRPr sz="1800"/>
+              <a:defRPr sz="2000"/>
             </a:pPr>
             <a:r>
-              <a:t>  - 自动驾驶与智能信号灯协同</a:t>
+              <a:t>AI治理制度化：隐私保护、算法审计、透明度与问责机制成为项目必选项。</a:t>
             </a:r>
           </a:p>
           <a:p>
             <a:pPr>
-              <a:spcBef>
-                <a:spcPts val="1200"/>
-              </a:spcBef>
-              <a:defRPr sz="1800"/>
+              <a:defRPr sz="2000"/>
             </a:pPr>
             <a:r>
-              <a:t>  - 实时路况预测与优化</a:t>
-            </a:r>
-          </a:p>
-          <a:p>
-            <a:pPr>
-              <a:spcBef>
-                <a:spcPts val="1200"/>
-              </a:spcBef>
-              <a:defRPr sz="1800"/>
-            </a:pPr>
-          </a:p>
-          <a:p>
-            <a:pPr>
-              <a:spcBef>
-                <a:spcPts val="1200"/>
-              </a:spcBef>
-              <a:defRPr sz="1800"/>
-            </a:pPr>
-            <a:r>
-              <a:t>• 智慧能源管理</a:t>
-            </a:r>
-          </a:p>
-          <a:p>
-            <a:pPr>
-              <a:spcBef>
-                <a:spcPts val="1200"/>
-              </a:spcBef>
-              <a:defRPr sz="1800"/>
-            </a:pPr>
-            <a:r>
-              <a:t>  - 虚拟电厂提供100MW备用电力</a:t>
-            </a:r>
-          </a:p>
-          <a:p>
-            <a:pPr>
-              <a:spcBef>
-                <a:spcPts val="1200"/>
-              </a:spcBef>
-              <a:defRPr sz="1800"/>
-            </a:pPr>
-            <a:r>
-              <a:t>  - AI优化能源分配，降低消耗</a:t>
-            </a:r>
-          </a:p>
-          <a:p>
-            <a:pPr>
-              <a:spcBef>
-                <a:spcPts val="1200"/>
-              </a:spcBef>
-              <a:defRPr sz="1800"/>
-            </a:pPr>
-            <a:r>
-              <a:t>  - 智能电网实时监控与调度</a:t>
+              <a:t>数据基础设施先行：高质量数据资产、标准化接口与跨部门数据协同成为成败关键。</a:t>
             </a:r>
           </a:p>
         </p:txBody>
@@ -4085,154 +3447,93 @@
       <p:grpSpPr/>
       <p:sp>
         <p:nvSpPr>
-          <p:cNvPr id="2" name="TextBox 1"/>
-          <p:cNvSpPr txBox="1"/>
-          <p:nvPr/>
-        </p:nvSpPr>
-        <p:spPr>
-          <a:xfrm>
-            <a:off x="457200" y="457200"/>
-            <a:ext cx="8229600" cy="731520"/>
-          </a:xfrm>
-          <a:prstGeom prst="rect">
-            <a:avLst/>
-          </a:prstGeom>
-          <a:noFill/>
-        </p:spPr>
-        <p:txBody>
-          <a:bodyPr wrap="none">
-            <a:spAutoFit/>
-          </a:bodyPr>
+          <p:cNvPr id="2" name="Title 1"/>
+          <p:cNvSpPr>
+            <a:spLocks noGrp="1"/>
+          </p:cNvSpPr>
+          <p:nvPr>
+            <p:ph type="title"/>
+          </p:nvPr>
+        </p:nvSpPr>
+        <p:spPr/>
+        <p:txBody>
+          <a:bodyPr/>
+          <a:lstStyle/>
+          <a:p>
+            <a:r>
+              <a:t>4. 成功案例分析</a:t>
+            </a:r>
+          </a:p>
+        </p:txBody>
+      </p:sp>
+      <p:sp>
+        <p:nvSpPr>
+          <p:cNvPr id="3" name="Content Placeholder 2"/>
+          <p:cNvSpPr>
+            <a:spLocks noGrp="1"/>
+          </p:cNvSpPr>
+          <p:nvPr>
+            <p:ph idx="1"/>
+          </p:nvPr>
+        </p:nvSpPr>
+        <p:spPr/>
+        <p:txBody>
+          <a:bodyPr/>
           <a:lstStyle/>
           <a:p>
             <a:pPr>
-              <a:defRPr sz="3200" b="1">
-                <a:solidFill>
-                  <a:srgbClr val="003366"/>
-                </a:solidFill>
-              </a:defRPr>
+              <a:defRPr sz="2000"/>
             </a:pPr>
             <a:r>
-              <a:t>2. AI在智慧城市中的主要应用场景（下）</a:t>
-            </a:r>
-          </a:p>
-        </p:txBody>
-      </p:sp>
-      <p:sp>
-        <p:nvSpPr>
-          <p:cNvPr id="3" name="TextBox 2"/>
-          <p:cNvSpPr txBox="1"/>
-          <p:nvPr/>
-        </p:nvSpPr>
-        <p:spPr>
-          <a:xfrm>
-            <a:off x="731520" y="1371600"/>
-            <a:ext cx="7772400" cy="5029200"/>
-          </a:xfrm>
-          <a:prstGeom prst="rect">
-            <a:avLst/>
-          </a:prstGeom>
-          <a:noFill/>
-        </p:spPr>
-        <p:txBody>
-          <a:bodyPr wrap="square">
-            <a:spAutoFit/>
-          </a:bodyPr>
-          <a:lstStyle/>
+              <a:t>案例A：杭州 City Brain 3.0（2025）</a:t>
+            </a:r>
+          </a:p>
+          <a:p>
+            <a:pPr lvl="1">
+              <a:defRPr sz="1600"/>
+            </a:pPr>
+            <a:r>
+              <a:t>引入AI模型与数字孪生，提升城市治理与公共服务效率。</a:t>
+            </a:r>
+          </a:p>
+          <a:p>
+            <a:pPr lvl="1">
+              <a:defRPr sz="1600"/>
+            </a:pPr>
+            <a:r>
+              <a:t>报道显示：地质勘测风险监测系统处理1,743个项目并发出2,434次风险预警。</a:t>
+            </a:r>
+          </a:p>
           <a:p>
             <a:pPr>
-              <a:spcBef>
-                <a:spcPts val="1200"/>
-              </a:spcBef>
-              <a:defRPr sz="1800"/>
+              <a:defRPr sz="2000"/>
             </a:pPr>
             <a:r>
-              <a:t>• 城市治理与公共安全</a:t>
+              <a:t>案例B：城市交通数字孪生（学术与产业趋势）</a:t>
+            </a:r>
+          </a:p>
+          <a:p>
+            <a:pPr lvl="1">
+              <a:defRPr sz="1600"/>
+            </a:pPr>
+            <a:r>
+              <a:t>交通系统通过AI+数字孪生进行流量预测、仿真与调度优化。</a:t>
             </a:r>
           </a:p>
           <a:p>
             <a:pPr>
-              <a:spcBef>
-                <a:spcPts val="1200"/>
-              </a:spcBef>
-              <a:defRPr sz="1800"/>
+              <a:defRPr sz="2000"/>
             </a:pPr>
             <a:r>
-              <a:t>  - AI视觉监控与异常检测</a:t>
-            </a:r>
-          </a:p>
-          <a:p>
-            <a:pPr>
-              <a:spcBef>
-                <a:spcPts val="1200"/>
-              </a:spcBef>
-              <a:defRPr sz="1800"/>
+              <a:t>案例C：全球城市治理框架升级</a:t>
+            </a:r>
+          </a:p>
+          <a:p>
+            <a:pPr lvl="1">
+              <a:defRPr sz="1600"/>
             </a:pPr>
             <a:r>
-              <a:t>  - 智能应急响应系统</a:t>
-            </a:r>
-          </a:p>
-          <a:p>
-            <a:pPr>
-              <a:spcBef>
-                <a:spcPts val="1200"/>
-              </a:spcBef>
-              <a:defRPr sz="1800"/>
-            </a:pPr>
-            <a:r>
-              <a:t>  - 公共数据流通与利用</a:t>
-            </a:r>
-          </a:p>
-          <a:p>
-            <a:pPr>
-              <a:spcBef>
-                <a:spcPts val="1200"/>
-              </a:spcBef>
-              <a:defRPr sz="1800"/>
-            </a:pPr>
-          </a:p>
-          <a:p>
-            <a:pPr>
-              <a:spcBef>
-                <a:spcPts val="1200"/>
-              </a:spcBef>
-              <a:defRPr sz="1800"/>
-            </a:pPr>
-            <a:r>
-              <a:t>• 智慧民生服务</a:t>
-            </a:r>
-          </a:p>
-          <a:p>
-            <a:pPr>
-              <a:spcBef>
-                <a:spcPts val="1200"/>
-              </a:spcBef>
-              <a:defRPr sz="1800"/>
-            </a:pPr>
-            <a:r>
-              <a:t>  - IoT废物管理网络减少卡车运行90%</a:t>
-            </a:r>
-          </a:p>
-          <a:p>
-            <a:pPr>
-              <a:spcBef>
-                <a:spcPts val="1200"/>
-              </a:spcBef>
-              <a:defRPr sz="1800"/>
-            </a:pPr>
-            <a:r>
-              <a:t>  - AI政务服务（公文处理、审核自动化）</a:t>
-            </a:r>
-          </a:p>
-          <a:p>
-            <a:pPr>
-              <a:spcBef>
-                <a:spcPts val="1200"/>
-              </a:spcBef>
-              <a:defRPr sz="1800"/>
-            </a:pPr>
-            <a:r>
-              <a:t>  - 智能医疗与健康监测</a:t>
+              <a:t>UN体系推动以人为本、责任AI与数据治理，为大规模应用提供制度保障。</a:t>
             </a:r>
           </a:p>
         </p:txBody>
@@ -4257,154 +3558,77 @@
       <p:grpSpPr/>
       <p:sp>
         <p:nvSpPr>
-          <p:cNvPr id="2" name="TextBox 1"/>
-          <p:cNvSpPr txBox="1"/>
-          <p:nvPr/>
-        </p:nvSpPr>
-        <p:spPr>
-          <a:xfrm>
-            <a:off x="457200" y="457200"/>
-            <a:ext cx="8229600" cy="731520"/>
-          </a:xfrm>
-          <a:prstGeom prst="rect">
-            <a:avLst/>
-          </a:prstGeom>
-          <a:noFill/>
-        </p:spPr>
-        <p:txBody>
-          <a:bodyPr wrap="none">
-            <a:spAutoFit/>
-          </a:bodyPr>
+          <p:cNvPr id="2" name="Title 1"/>
+          <p:cNvSpPr>
+            <a:spLocks noGrp="1"/>
+          </p:cNvSpPr>
+          <p:nvPr>
+            <p:ph type="title"/>
+          </p:nvPr>
+        </p:nvSpPr>
+        <p:spPr/>
+        <p:txBody>
+          <a:bodyPr/>
+          <a:lstStyle/>
+          <a:p>
+            <a:r>
+              <a:t>5. 未来展望（2026-2030）</a:t>
+            </a:r>
+          </a:p>
+        </p:txBody>
+      </p:sp>
+      <p:sp>
+        <p:nvSpPr>
+          <p:cNvPr id="3" name="Content Placeholder 2"/>
+          <p:cNvSpPr>
+            <a:spLocks noGrp="1"/>
+          </p:cNvSpPr>
+          <p:nvPr>
+            <p:ph idx="1"/>
+          </p:nvPr>
+        </p:nvSpPr>
+        <p:spPr/>
+        <p:txBody>
+          <a:bodyPr/>
           <a:lstStyle/>
           <a:p>
             <a:pPr>
-              <a:defRPr sz="3200" b="1">
-                <a:solidFill>
-                  <a:srgbClr val="003366"/>
-                </a:solidFill>
-              </a:defRPr>
+              <a:defRPr sz="2000"/>
             </a:pPr>
             <a:r>
-              <a:t>3. 2026年最新技术和趋势（上）</a:t>
-            </a:r>
-          </a:p>
-        </p:txBody>
-      </p:sp>
-      <p:sp>
-        <p:nvSpPr>
-          <p:cNvPr id="3" name="TextBox 2"/>
-          <p:cNvSpPr txBox="1"/>
-          <p:nvPr/>
-        </p:nvSpPr>
-        <p:spPr>
-          <a:xfrm>
-            <a:off x="731520" y="1371600"/>
-            <a:ext cx="7772400" cy="5029200"/>
-          </a:xfrm>
-          <a:prstGeom prst="rect">
-            <a:avLst/>
-          </a:prstGeom>
-          <a:noFill/>
-        </p:spPr>
-        <p:txBody>
-          <a:bodyPr wrap="square">
-            <a:spAutoFit/>
-          </a:bodyPr>
-          <a:lstStyle/>
+              <a:t>从单点智能走向‘城市智能体’：跨交通、能源、安全、政务的协同优化。</a:t>
+            </a:r>
+          </a:p>
           <a:p>
             <a:pPr>
-              <a:spcBef>
-                <a:spcPts val="1200"/>
-              </a:spcBef>
-              <a:defRPr sz="1800"/>
+              <a:defRPr sz="2000"/>
             </a:pPr>
             <a:r>
-              <a:t>• Agentic AI（智能体AI）</a:t>
+              <a:t>从项目试点走向平台化运营：统一城市AI中台+场景应用生态。</a:t>
             </a:r>
           </a:p>
           <a:p>
             <a:pPr>
-              <a:spcBef>
-                <a:spcPts val="1200"/>
-              </a:spcBef>
-              <a:defRPr sz="1800"/>
+              <a:defRPr sz="2000"/>
             </a:pPr>
             <a:r>
-              <a:t>  - 到2027年，中国70%的城市将部署AI智能体</a:t>
+              <a:t>从效率优先走向‘效率+韧性+公平’三目标平衡。</a:t>
             </a:r>
           </a:p>
           <a:p>
             <a:pPr>
-              <a:spcBef>
-                <a:spcPts val="1200"/>
-              </a:spcBef>
-              <a:defRPr sz="1800"/>
+              <a:defRPr sz="2000"/>
             </a:pPr>
             <a:r>
-              <a:t>  - 协同端到端工作流程，减轻工作量</a:t>
+              <a:t>关键挑战：数据孤岛、模型偏差、网络安全、组织协同与人才缺口。</a:t>
             </a:r>
           </a:p>
           <a:p>
             <a:pPr>
-              <a:spcBef>
-                <a:spcPts val="1200"/>
-              </a:spcBef>
-              <a:defRPr sz="1800"/>
+              <a:defRPr sz="2000"/>
             </a:pPr>
             <a:r>
-              <a:t>  - 自主决策与跨系统协作</a:t>
-            </a:r>
-          </a:p>
-          <a:p>
-            <a:pPr>
-              <a:spcBef>
-                <a:spcPts val="1200"/>
-              </a:spcBef>
-              <a:defRPr sz="1800"/>
-            </a:pPr>
-          </a:p>
-          <a:p>
-            <a:pPr>
-              <a:spcBef>
-                <a:spcPts val="1200"/>
-              </a:spcBef>
-              <a:defRPr sz="1800"/>
-            </a:pPr>
-            <a:r>
-              <a:t>• 生成式AI（GenAI）</a:t>
-            </a:r>
-          </a:p>
-          <a:p>
-            <a:pPr>
-              <a:spcBef>
-                <a:spcPts val="1200"/>
-              </a:spcBef>
-              <a:defRPr sz="1800"/>
-            </a:pPr>
-            <a:r>
-              <a:t>  - 解锁数十年隐藏的政府数据</a:t>
-            </a:r>
-          </a:p>
-          <a:p>
-            <a:pPr>
-              <a:spcBef>
-                <a:spcPts val="1200"/>
-              </a:spcBef>
-              <a:defRPr sz="1800"/>
-            </a:pPr>
-            <a:r>
-              <a:t>  - 自动化文档处理与知识提取</a:t>
-            </a:r>
-          </a:p>
-          <a:p>
-            <a:pPr>
-              <a:spcBef>
-                <a:spcPts val="1200"/>
-              </a:spcBef>
-              <a:defRPr sz="1800"/>
-            </a:pPr>
-            <a:r>
-              <a:t>  - 精细调优的大语言模型（LLM）应用</a:t>
+              <a:t>建议路径：先数据治理、再场景落地、同步建立伦理与监管机制。</a:t>
             </a:r>
           </a:p>
         </p:txBody>
@@ -4429,14 +3653,35 @@
       <p:grpSpPr/>
       <p:sp>
         <p:nvSpPr>
-          <p:cNvPr id="2" name="TextBox 1"/>
+          <p:cNvPr id="2" name="Title 1"/>
+          <p:cNvSpPr>
+            <a:spLocks noGrp="1"/>
+          </p:cNvSpPr>
+          <p:nvPr>
+            <p:ph type="title"/>
+          </p:nvPr>
+        </p:nvSpPr>
+        <p:spPr/>
+        <p:txBody>
+          <a:bodyPr/>
+          <a:lstStyle/>
+          <a:p>
+            <a:r>
+              <a:t>结论与建议</a:t>
+            </a:r>
+          </a:p>
+        </p:txBody>
+      </p:sp>
+      <p:sp>
+        <p:nvSpPr>
+          <p:cNvPr id="3" name="TextBox 2"/>
           <p:cNvSpPr txBox="1"/>
           <p:nvPr/>
         </p:nvSpPr>
         <p:spPr>
           <a:xfrm>
-            <a:off x="457200" y="457200"/>
-            <a:ext cx="8229600" cy="731520"/>
+            <a:off x="731520" y="1645920"/>
+            <a:ext cx="10515600" cy="4114800"/>
           </a:xfrm>
           <a:prstGeom prst="rect">
             <a:avLst/>
@@ -4450,133 +3695,18 @@
           <a:lstStyle/>
           <a:p>
             <a:pPr>
-              <a:defRPr sz="3200" b="1">
-                <a:solidFill>
-                  <a:srgbClr val="003366"/>
-                </a:solidFill>
-              </a:defRPr>
+              <a:defRPr sz="3400" b="1"/>
             </a:pPr>
             <a:r>
-              <a:t>3. 2026年最新技术和趋势（下）</a:t>
-            </a:r>
-          </a:p>
-        </p:txBody>
-      </p:sp>
-      <p:sp>
-        <p:nvSpPr>
-          <p:cNvPr id="3" name="TextBox 2"/>
-          <p:cNvSpPr txBox="1"/>
-          <p:nvPr/>
-        </p:nvSpPr>
-        <p:spPr>
-          <a:xfrm>
-            <a:off x="731520" y="1371600"/>
-            <a:ext cx="7772400" cy="5029200"/>
-          </a:xfrm>
-          <a:prstGeom prst="rect">
-            <a:avLst/>
-          </a:prstGeom>
-          <a:noFill/>
-        </p:spPr>
-        <p:txBody>
-          <a:bodyPr wrap="square">
-            <a:spAutoFit/>
-          </a:bodyPr>
-          <a:lstStyle/>
+              <a:t>2026年，AI正在成为智慧城市的“操作系统”。</a:t>
+            </a:r>
+          </a:p>
           <a:p>
             <a:pPr>
-              <a:spcBef>
-                <a:spcPts val="1200"/>
-              </a:spcBef>
-              <a:defRPr sz="1800"/>
+              <a:defRPr sz="2200"/>
             </a:pPr>
             <a:r>
-              <a:t>• 边缘智能与IoT融合</a:t>
-            </a:r>
-          </a:p>
-          <a:p>
-            <a:pPr>
-              <a:spcBef>
-                <a:spcPts val="1200"/>
-              </a:spcBef>
-              <a:defRPr sz="1800"/>
-            </a:pPr>
-            <a:r>
-              <a:t>  - 边缘计算降低延迟，提升响应速度</a:t>
-            </a:r>
-          </a:p>
-          <a:p>
-            <a:pPr>
-              <a:spcBef>
-                <a:spcPts val="1200"/>
-              </a:spcBef>
-              <a:defRPr sz="1800"/>
-            </a:pPr>
-            <a:r>
-              <a:t>  - IoT设备与AI模型本地化部署</a:t>
-            </a:r>
-          </a:p>
-          <a:p>
-            <a:pPr>
-              <a:spcBef>
-                <a:spcPts val="1200"/>
-              </a:spcBef>
-              <a:defRPr sz="1800"/>
-            </a:pPr>
-            <a:r>
-              <a:t>  - 5G网络支撑海量设备连接</a:t>
-            </a:r>
-          </a:p>
-          <a:p>
-            <a:pPr>
-              <a:spcBef>
-                <a:spcPts val="1200"/>
-              </a:spcBef>
-              <a:defRPr sz="1800"/>
-            </a:pPr>
-          </a:p>
-          <a:p>
-            <a:pPr>
-              <a:spcBef>
-                <a:spcPts val="1200"/>
-              </a:spcBef>
-              <a:defRPr sz="1800"/>
-            </a:pPr>
-            <a:r>
-              <a:t>• 数字孪生城市</a:t>
-            </a:r>
-          </a:p>
-          <a:p>
-            <a:pPr>
-              <a:spcBef>
-                <a:spcPts val="1200"/>
-              </a:spcBef>
-              <a:defRPr sz="1800"/>
-            </a:pPr>
-            <a:r>
-              <a:t>  - 虚拟城市模型实时同步物理世界</a:t>
-            </a:r>
-          </a:p>
-          <a:p>
-            <a:pPr>
-              <a:spcBef>
-                <a:spcPts val="1200"/>
-              </a:spcBef>
-              <a:defRPr sz="1800"/>
-            </a:pPr>
-            <a:r>
-              <a:t>  - 在建设前测试城市决策</a:t>
-            </a:r>
-          </a:p>
-          <a:p>
-            <a:pPr>
-              <a:spcBef>
-                <a:spcPts val="1200"/>
-              </a:spcBef>
-              <a:defRPr sz="1800"/>
-            </a:pPr>
-            <a:r>
-              <a:t>  - 预测性维护与资源优化</a:t>
+              <a:t>优先建设可信数据与治理体系，在高价值场景形成可复制的运营闭环，是城市实现规模化智能升级的关键。</a:t>
             </a:r>
           </a:p>
         </p:txBody>
@@ -4601,326 +3731,101 @@
       <p:grpSpPr/>
       <p:sp>
         <p:nvSpPr>
-          <p:cNvPr id="2" name="TextBox 1"/>
-          <p:cNvSpPr txBox="1"/>
-          <p:nvPr/>
-        </p:nvSpPr>
-        <p:spPr>
-          <a:xfrm>
-            <a:off x="457200" y="457200"/>
-            <a:ext cx="8229600" cy="731520"/>
-          </a:xfrm>
-          <a:prstGeom prst="rect">
-            <a:avLst/>
-          </a:prstGeom>
-          <a:noFill/>
-        </p:spPr>
-        <p:txBody>
-          <a:bodyPr wrap="none">
-            <a:spAutoFit/>
-          </a:bodyPr>
+          <p:cNvPr id="2" name="Title 1"/>
+          <p:cNvSpPr>
+            <a:spLocks noGrp="1"/>
+          </p:cNvSpPr>
+          <p:nvPr>
+            <p:ph type="title"/>
+          </p:nvPr>
+        </p:nvSpPr>
+        <p:spPr/>
+        <p:txBody>
+          <a:bodyPr/>
+          <a:lstStyle/>
+          <a:p>
+            <a:r>
+              <a:t>参考资料（公开来源）</a:t>
+            </a:r>
+          </a:p>
+        </p:txBody>
+      </p:sp>
+      <p:sp>
+        <p:nvSpPr>
+          <p:cNvPr id="3" name="Content Placeholder 2"/>
+          <p:cNvSpPr>
+            <a:spLocks noGrp="1"/>
+          </p:cNvSpPr>
+          <p:nvPr>
+            <p:ph idx="1"/>
+          </p:nvPr>
+        </p:nvSpPr>
+        <p:spPr/>
+        <p:txBody>
+          <a:bodyPr/>
           <a:lstStyle/>
           <a:p>
             <a:pPr>
-              <a:defRPr sz="3200" b="1">
-                <a:solidFill>
-                  <a:srgbClr val="003366"/>
-                </a:solidFill>
-              </a:defRPr>
+              <a:defRPr sz="1400"/>
             </a:pPr>
             <a:r>
-              <a:t>4. 成功案例分析（上）</a:t>
-            </a:r>
-          </a:p>
-        </p:txBody>
-      </p:sp>
-      <p:sp>
-        <p:nvSpPr>
-          <p:cNvPr id="3" name="TextBox 2"/>
-          <p:cNvSpPr txBox="1"/>
-          <p:nvPr/>
-        </p:nvSpPr>
-        <p:spPr>
-          <a:xfrm>
-            <a:off x="731520" y="1371600"/>
-            <a:ext cx="7772400" cy="5029200"/>
-          </a:xfrm>
-          <a:prstGeom prst="rect">
-            <a:avLst/>
-          </a:prstGeom>
-          <a:noFill/>
-        </p:spPr>
-        <p:txBody>
-          <a:bodyPr wrap="square">
-            <a:spAutoFit/>
-          </a:bodyPr>
-          <a:lstStyle/>
+              <a:t>UN-Habitat (2025): International Guidelines on People-Centred Smart Cities</a:t>
+            </a:r>
+          </a:p>
           <a:p>
             <a:pPr>
-              <a:spcBef>
-                <a:spcPts val="1200"/>
-              </a:spcBef>
-              <a:defRPr sz="1800"/>
+              <a:defRPr sz="1400"/>
             </a:pPr>
             <a:r>
-              <a:t>• 案例1：中国城市AI智能体部署</a:t>
+              <a:t>https://unhabitat.org/sites/default/files/2025/03/international_guidelines_on_people_centred_smart_cities_clean_6.3.2025_1.pdf</a:t>
             </a:r>
           </a:p>
           <a:p>
             <a:pPr>
-              <a:spcBef>
-                <a:spcPts val="1200"/>
-              </a:spcBef>
-              <a:defRPr sz="1800"/>
+              <a:defRPr sz="1400"/>
             </a:pPr>
             <a:r>
-              <a:t>  - 覆盖范围：预计2027年70%的中国城市</a:t>
+              <a:t>Hangzhou City Brain 3.0 (2025-04-01)</a:t>
             </a:r>
           </a:p>
           <a:p>
             <a:pPr>
-              <a:spcBef>
-                <a:spcPts val="1200"/>
-              </a:spcBef>
-              <a:defRPr sz="1800"/>
+              <a:defRPr sz="1400"/>
             </a:pPr>
             <a:r>
-              <a:t>  - 应用场景：交通调度、能源管理、应急响应</a:t>
+              <a:t>https://www.ehangzhou.gov.cn/2025-04/01/c_293162.htm</a:t>
             </a:r>
           </a:p>
           <a:p>
             <a:pPr>
-              <a:spcBef>
-                <a:spcPts val="1200"/>
-              </a:spcBef>
-              <a:defRPr sz="1800"/>
+              <a:defRPr sz="1400"/>
             </a:pPr>
             <a:r>
-              <a:t>  - 成效：工作流程自动化，效率提升30%+</a:t>
+              <a:t>Smart Cities World: How AI will define cities and mobility in 2026</a:t>
             </a:r>
           </a:p>
           <a:p>
             <a:pPr>
-              <a:spcBef>
-                <a:spcPts val="1200"/>
-              </a:spcBef>
-              <a:defRPr sz="1800"/>
+              <a:defRPr sz="1400"/>
             </a:pPr>
+            <a:r>
+              <a:t>https://www.smartcitiesworld.net/ai-and-machine-learning/how-ai-will-define-cities-and-mobility-in-2026</a:t>
+            </a:r>
           </a:p>
           <a:p>
             <a:pPr>
-              <a:spcBef>
-                <a:spcPts val="1200"/>
-              </a:spcBef>
-              <a:defRPr sz="1800"/>
+              <a:defRPr sz="1400"/>
             </a:pPr>
             <a:r>
-              <a:t>• 案例2：广州天河区智慧政务</a:t>
+              <a:t>ArXiv: AI-Powered Urban Transportation Digital Twin: Methods and Applications</a:t>
             </a:r>
           </a:p>
           <a:p>
             <a:pPr>
-              <a:spcBef>
-                <a:spcPts val="1200"/>
-              </a:spcBef>
-              <a:defRPr sz="1800"/>
+              <a:defRPr sz="1400"/>
             </a:pPr>
             <a:r>
-              <a:t>  - 京华信息智慧政务入选AI场景应用案例集</a:t>
-            </a:r>
-          </a:p>
-          <a:p>
-            <a:pPr>
-              <a:spcBef>
-                <a:spcPts val="1200"/>
-              </a:spcBef>
-              <a:defRPr sz="1800"/>
-            </a:pPr>
-            <a:r>
-              <a:t>  - AI技术应用于公文处理、审核、项目管理</a:t>
-            </a:r>
-          </a:p>
-          <a:p>
-            <a:pPr>
-              <a:spcBef>
-                <a:spcPts val="1200"/>
-              </a:spcBef>
-              <a:defRPr sz="1800"/>
-            </a:pPr>
-            <a:r>
-              <a:t>  - 交通热线服务智能化升级</a:t>
-            </a:r>
-          </a:p>
-        </p:txBody>
-      </p:sp>
-    </p:spTree>
-  </p:cSld>
-  <p:clrMapOvr>
-    <a:masterClrMapping/>
-  </p:clrMapOvr>
-</p:sld>
-</file>
-
-<file path=ppt/slides/slide9.xml><?xml version="1.0" encoding="utf-8"?>
-<p:sld xmlns:a="http://schemas.openxmlformats.org/drawingml/2006/main" xmlns:p="http://schemas.openxmlformats.org/presentationml/2006/main" xmlns:r="http://schemas.openxmlformats.org/officeDocument/2006/relationships">
-  <p:cSld>
-    <p:spTree>
-      <p:nvGrpSpPr>
-        <p:cNvPr id="1" name=""/>
-        <p:cNvGrpSpPr/>
-        <p:nvPr/>
-      </p:nvGrpSpPr>
-      <p:grpSpPr/>
-      <p:sp>
-        <p:nvSpPr>
-          <p:cNvPr id="2" name="TextBox 1"/>
-          <p:cNvSpPr txBox="1"/>
-          <p:nvPr/>
-        </p:nvSpPr>
-        <p:spPr>
-          <a:xfrm>
-            <a:off x="457200" y="457200"/>
-            <a:ext cx="8229600" cy="731520"/>
-          </a:xfrm>
-          <a:prstGeom prst="rect">
-            <a:avLst/>
-          </a:prstGeom>
-          <a:noFill/>
-        </p:spPr>
-        <p:txBody>
-          <a:bodyPr wrap="none">
-            <a:spAutoFit/>
-          </a:bodyPr>
-          <a:lstStyle/>
-          <a:p>
-            <a:pPr>
-              <a:defRPr sz="3200" b="1">
-                <a:solidFill>
-                  <a:srgbClr val="003366"/>
-                </a:solidFill>
-              </a:defRPr>
-            </a:pPr>
-            <a:r>
-              <a:t>4. 成功案例分析（下）</a:t>
-            </a:r>
-          </a:p>
-        </p:txBody>
-      </p:sp>
-      <p:sp>
-        <p:nvSpPr>
-          <p:cNvPr id="3" name="TextBox 2"/>
-          <p:cNvSpPr txBox="1"/>
-          <p:nvPr/>
-        </p:nvSpPr>
-        <p:spPr>
-          <a:xfrm>
-            <a:off x="731520" y="1371600"/>
-            <a:ext cx="7772400" cy="5029200"/>
-          </a:xfrm>
-          <a:prstGeom prst="rect">
-            <a:avLst/>
-          </a:prstGeom>
-          <a:noFill/>
-        </p:spPr>
-        <p:txBody>
-          <a:bodyPr wrap="square">
-            <a:spAutoFit/>
-          </a:bodyPr>
-          <a:lstStyle/>
-          <a:p>
-            <a:pPr>
-              <a:spcBef>
-                <a:spcPts val="1200"/>
-              </a:spcBef>
-              <a:defRPr sz="1800"/>
-            </a:pPr>
-            <a:r>
-              <a:t>• 案例3：高雄智慧城市展（2026年3月）</a:t>
-            </a:r>
-          </a:p>
-          <a:p>
-            <a:pPr>
-              <a:spcBef>
-                <a:spcPts val="1200"/>
-              </a:spcBef>
-              <a:defRPr sz="1800"/>
-            </a:pPr>
-            <a:r>
-              <a:t>  - 展示5年智慧城市建设成果</a:t>
-            </a:r>
-          </a:p>
-          <a:p>
-            <a:pPr>
-              <a:spcBef>
-                <a:spcPts val="1200"/>
-              </a:spcBef>
-              <a:defRPr sz="1800"/>
-            </a:pPr>
-            <a:r>
-              <a:t>  - AI应用覆盖城市生活各面向</a:t>
-            </a:r>
-          </a:p>
-          <a:p>
-            <a:pPr>
-              <a:spcBef>
-                <a:spcPts val="1200"/>
-              </a:spcBef>
-              <a:defRPr sz="1800"/>
-            </a:pPr>
-            <a:r>
-              <a:t>  - 深入生活场景的AI成果展示</a:t>
-            </a:r>
-          </a:p>
-          <a:p>
-            <a:pPr>
-              <a:spcBef>
-                <a:spcPts val="1200"/>
-              </a:spcBef>
-              <a:defRPr sz="1800"/>
-            </a:pPr>
-          </a:p>
-          <a:p>
-            <a:pPr>
-              <a:spcBef>
-                <a:spcPts val="1200"/>
-              </a:spcBef>
-              <a:defRPr sz="1800"/>
-            </a:pPr>
-            <a:r>
-              <a:t>• 案例4：Sunnyvale（硅谷核心城市）</a:t>
-            </a:r>
-          </a:p>
-          <a:p>
-            <a:pPr>
-              <a:spcBef>
-                <a:spcPts val="1200"/>
-              </a:spcBef>
-              <a:defRPr sz="1800"/>
-            </a:pPr>
-            <a:r>
-              <a:t>  - 市长Larry Klein：AI正在影响所有城市</a:t>
-            </a:r>
-          </a:p>
-          <a:p>
-            <a:pPr>
-              <a:spcBef>
-                <a:spcPts val="1200"/>
-              </a:spcBef>
-              <a:defRPr sz="1800"/>
-            </a:pPr>
-            <a:r>
-              <a:t>  - 智能许可审批与城市规划</a:t>
-            </a:r>
-          </a:p>
-          <a:p>
-            <a:pPr>
-              <a:spcBef>
-                <a:spcPts val="1200"/>
-              </a:spcBef>
-              <a:defRPr sz="1800"/>
-            </a:pPr>
-            <a:r>
-              <a:t>  - 公民服务与资产管理智能化</a:t>
+              <a:t>https://arxiv.org/html/2501.10396v1</a:t>
             </a:r>
           </a:p>
         </p:txBody>

</xml_diff>